<commit_message>
Add Extended Knowledge and SAC Briefing sections to all 4 PowerPoint decks
Each unit's PowerPoint previously only covered the core topic slide decks;
the new Word-only content (Extended Knowledge, SAC packs) had no slide
presence for in-class teaching. Extends each deck with two more topic
sections, rendered with the same shape-based design system:

- Extended Knowledge section: one slide per knowledge area (colour
  psychology, design movements, semiotics, grid systems, materials and
  manufacturing, career pathways, etc. -- matching each unit's
  Extended-Knowledge.docx)
- SAC Briefing section: one slide per outcome summarising the task,
  conditions and marking criteria, so it can be presented to students
  ahead of a SAC (still flagged as draft -- confirm against the school's
  SAC schedule and the current VCAA study design)

Slide counts: Unit 1 60->70, Unit 2 17->27, Unit 3 16->26, Unit 4 16->26.
index.html's PowerPoint download links updated to mention the added
content.
</commit_message>
<xml_diff>
--- a/teaching-materials/vcd-vce/powerpoint/Unit1-Finding-Design-Solutions.pptx
+++ b/teaching-materials/vcd-vce/powerpoint/Unit1-Finding-Design-Solutions.pptx
@@ -65,6 +65,16 @@
     <p:sldId id="313" r:id="rId64"/>
     <p:sldId id="314" r:id="rId65"/>
     <p:sldId id="315" r:id="rId66"/>
+    <p:sldId id="316" r:id="rId67"/>
+    <p:sldId id="317" r:id="rId68"/>
+    <p:sldId id="318" r:id="rId69"/>
+    <p:sldId id="319" r:id="rId70"/>
+    <p:sldId id="320" r:id="rId71"/>
+    <p:sldId id="321" r:id="rId72"/>
+    <p:sldId id="322" r:id="rId73"/>
+    <p:sldId id="323" r:id="rId74"/>
+    <p:sldId id="324" r:id="rId75"/>
+    <p:sldId id="325" r:id="rId76"/>
   </p:sldIdLst>
   <p:sldSz cx="12191695" cy="6858000" type="screen4x3"/>
   <p:notesSz cx="6858000" cy="9144000"/>
@@ -28485,8 +28495,8 @@
         </p:nvSpPr>
         <p:spPr>
           <a:xfrm>
-            <a:off x="-1097280" y="4114800"/>
-            <a:ext cx="3108960" cy="3108960"/>
+            <a:off x="9692640" y="-914400"/>
+            <a:ext cx="2926080" cy="2926080"/>
           </a:xfrm>
           <a:prstGeom prst="ellipse">
             <a:avLst/>
@@ -28529,14 +28539,14 @@
         </p:nvSpPr>
         <p:spPr>
           <a:xfrm>
-            <a:off x="9875520" y="-1188720"/>
-            <a:ext cx="2743200" cy="2743200"/>
+            <a:off x="-914400" y="4937760"/>
+            <a:ext cx="2377440" cy="2377440"/>
           </a:xfrm>
           <a:prstGeom prst="ellipse">
             <a:avLst/>
           </a:prstGeom>
           <a:solidFill>
-            <a:srgbClr val="E8A23A"/>
+            <a:srgbClr val="1B615E"/>
           </a:solidFill>
           <a:ln>
             <a:noFill/>
@@ -28573,12 +28583,12 @@
         </p:nvSpPr>
         <p:spPr>
           <a:xfrm>
-            <a:off x="1920240" y="2286000"/>
-            <a:ext cx="8321040" cy="2377440"/>
+            <a:off x="822960" y="1051560"/>
+            <a:ext cx="1188720" cy="502920"/>
           </a:xfrm>
           <a:prstGeom prst="roundRect">
             <a:avLst>
-              <a:gd name="adj" fmla="val 20000"/>
+              <a:gd name="adj" fmla="val 50000"/>
             </a:avLst>
           </a:prstGeom>
           <a:solidFill>
@@ -28604,30 +28614,3584 @@
           </a:fontRef>
         </p:style>
         <p:txBody>
+          <a:bodyPr rtlCol="0" anchor="ctr" wrap="none" lIns="50800" rIns="50800"/>
+          <a:lstStyle/>
+          <a:p>
+            <a:pPr algn="ctr"/>
+            <a:r>
+              <a:rPr sz="1400" b="1">
+                <a:solidFill>
+                  <a:srgbClr val="185855"/>
+                </a:solidFill>
+                <a:latin typeface="Calibri"/>
+              </a:rPr>
+              <a:t>06</a:t>
+            </a:r>
+          </a:p>
+        </p:txBody>
+      </p:sp>
+      <p:sp>
+        <p:nvSpPr>
+          <p:cNvPr id="5" name="Rounded Rectangle 4"/>
+          <p:cNvSpPr/>
+          <p:nvPr/>
+        </p:nvSpPr>
+        <p:spPr>
+          <a:xfrm>
+            <a:off x="822960" y="2011680"/>
+            <a:ext cx="10515600" cy="2834640"/>
+          </a:xfrm>
+          <a:prstGeom prst="roundRect">
+            <a:avLst>
+              <a:gd name="adj" fmla="val 18000"/>
+            </a:avLst>
+          </a:prstGeom>
+          <a:solidFill>
+            <a:srgbClr val="FFFFFF"/>
+          </a:solidFill>
+          <a:ln>
+            <a:noFill/>
+          </a:ln>
+          <a:effectLst/>
+        </p:spPr>
+        <p:style>
+          <a:lnRef idx="1">
+            <a:schemeClr val="accent1"/>
+          </a:lnRef>
+          <a:fillRef idx="3">
+            <a:schemeClr val="accent1"/>
+          </a:fillRef>
+          <a:effectRef idx="2">
+            <a:schemeClr val="accent1"/>
+          </a:effectRef>
+          <a:fontRef idx="minor">
+            <a:schemeClr val="lt1"/>
+          </a:fontRef>
+        </p:style>
+        <p:txBody>
           <a:bodyPr rtlCol="0" anchor="ctr"/>
           <a:lstStyle/>
           <a:p>
             <a:pPr algn="ctr"/>
-            <a:r>
-              <a:rPr b="1" sz="3000">
-                <a:solidFill>
-                  <a:srgbClr val="1F6F6B"/>
+          </a:p>
+        </p:txBody>
+      </p:sp>
+      <p:sp>
+        <p:nvSpPr>
+          <p:cNvPr id="6" name="TextBox 5"/>
+          <p:cNvSpPr txBox="1"/>
+          <p:nvPr/>
+        </p:nvSpPr>
+        <p:spPr>
+          <a:xfrm>
+            <a:off x="1280160" y="2697480"/>
+            <a:ext cx="9601200" cy="1097280"/>
+          </a:xfrm>
+          <a:prstGeom prst="rect">
+            <a:avLst/>
+          </a:prstGeom>
+          <a:noFill/>
+        </p:spPr>
+        <p:txBody>
+          <a:bodyPr wrap="square" anchor="t">
+            <a:spAutoFit/>
+          </a:bodyPr>
+          <a:lstStyle/>
+          <a:p>
+            <a:pPr algn="l"/>
+            <a:r>
+              <a:rPr sz="3400" b="1" i="0">
+                <a:solidFill>
+                  <a:srgbClr val="1A5E5A"/>
                 </a:solidFill>
                 <a:latin typeface="Cambria"/>
               </a:rPr>
-              <a:t>End of Unit 1</a:t>
-            </a:r>
-          </a:p>
+              <a:t>Extended Knowledge</a:t>
+            </a:r>
+          </a:p>
+        </p:txBody>
+      </p:sp>
+      <p:sp>
+        <p:nvSpPr>
+          <p:cNvPr id="7" name="TextBox 6"/>
+          <p:cNvSpPr txBox="1"/>
+          <p:nvPr/>
+        </p:nvSpPr>
+        <p:spPr>
+          <a:xfrm>
+            <a:off x="1280160" y="3657600"/>
+            <a:ext cx="9601200" cy="548640"/>
+          </a:xfrm>
+          <a:prstGeom prst="rect">
+            <a:avLst/>
+          </a:prstGeom>
+          <a:noFill/>
+        </p:spPr>
+        <p:txBody>
+          <a:bodyPr wrap="square" anchor="t">
+            <a:spAutoFit/>
+          </a:bodyPr>
+          <a:lstStyle/>
+          <a:p>
+            <a:pPr algn="l"/>
+            <a:r>
+              <a:rPr sz="1500" b="0" i="0">
+                <a:solidFill>
+                  <a:srgbClr val="6B6B6B"/>
+                </a:solidFill>
+                <a:latin typeface="Calibri"/>
+              </a:rPr>
+              <a:t>Beyond the study design</a:t>
+            </a:r>
+          </a:p>
+        </p:txBody>
+      </p:sp>
+    </p:spTree>
+  </p:cSld>
+  <p:clrMapOvr>
+    <a:masterClrMapping/>
+  </p:clrMapOvr>
+</p:sld>
+</file>
+
+<file path=ppt/slides/slide61.xml><?xml version="1.0" encoding="utf-8"?>
+<p:sld xmlns:a="http://schemas.openxmlformats.org/drawingml/2006/main" xmlns:p="http://schemas.openxmlformats.org/presentationml/2006/main" xmlns:r="http://schemas.openxmlformats.org/officeDocument/2006/relationships">
+  <p:cSld>
+    <p:bg>
+      <p:bgPr>
+        <a:solidFill>
+          <a:srgbClr val="FCF8F1"/>
+        </a:solidFill>
+        <a:effectLst/>
+      </p:bgPr>
+    </p:bg>
+    <p:spTree>
+      <p:nvGrpSpPr>
+        <p:cNvPr id="1" name=""/>
+        <p:cNvGrpSpPr/>
+        <p:nvPr/>
+      </p:nvGrpSpPr>
+      <p:grpSpPr/>
+      <p:sp>
+        <p:nvSpPr>
+          <p:cNvPr id="2" name="Rounded Rectangle 1"/>
+          <p:cNvSpPr/>
+          <p:nvPr/>
+        </p:nvSpPr>
+        <p:spPr>
+          <a:xfrm>
+            <a:off x="685800" y="502920"/>
+            <a:ext cx="3291840" cy="457200"/>
+          </a:xfrm>
+          <a:prstGeom prst="roundRect">
+            <a:avLst>
+              <a:gd name="adj" fmla="val 50000"/>
+            </a:avLst>
+          </a:prstGeom>
+          <a:solidFill>
+            <a:srgbClr val="1F6F6B"/>
+          </a:solidFill>
+          <a:ln>
+            <a:noFill/>
+          </a:ln>
+          <a:effectLst/>
+        </p:spPr>
+        <p:style>
+          <a:lnRef idx="1">
+            <a:schemeClr val="accent1"/>
+          </a:lnRef>
+          <a:fillRef idx="3">
+            <a:schemeClr val="accent1"/>
+          </a:fillRef>
+          <a:effectRef idx="2">
+            <a:schemeClr val="accent1"/>
+          </a:effectRef>
+          <a:fontRef idx="minor">
+            <a:schemeClr val="lt1"/>
+          </a:fontRef>
+        </p:style>
+        <p:txBody>
+          <a:bodyPr rtlCol="0" anchor="ctr" wrap="none" lIns="50800" rIns="50800"/>
+          <a:lstStyle/>
           <a:p>
             <a:pPr algn="ctr"/>
             <a:r>
-              <a:rPr sz="1400">
-                <a:solidFill>
-                  <a:srgbClr val="595959"/>
-                </a:solidFill>
-              </a:rPr>
-              <a:t>Review the matching workbook to consolidate what you have learnt.</a:t>
-            </a:r>
+              <a:rPr sz="1100" b="1">
+                <a:solidFill>
+                  <a:srgbClr val="FFFFFF"/>
+                </a:solidFill>
+                <a:latin typeface="Calibri"/>
+              </a:rPr>
+              <a:t>EXTENDED KNOWLEDGE</a:t>
+            </a:r>
+          </a:p>
+        </p:txBody>
+      </p:sp>
+      <p:sp>
+        <p:nvSpPr>
+          <p:cNvPr id="3" name="TextBox 2"/>
+          <p:cNvSpPr txBox="1"/>
+          <p:nvPr/>
+        </p:nvSpPr>
+        <p:spPr>
+          <a:xfrm>
+            <a:off x="685800" y="1051560"/>
+            <a:ext cx="10607040" cy="822960"/>
+          </a:xfrm>
+          <a:prstGeom prst="rect">
+            <a:avLst/>
+          </a:prstGeom>
+          <a:noFill/>
+        </p:spPr>
+        <p:txBody>
+          <a:bodyPr wrap="square" anchor="t">
+            <a:spAutoFit/>
+          </a:bodyPr>
+          <a:lstStyle/>
+          <a:p>
+            <a:pPr algn="l"/>
+            <a:r>
+              <a:rPr sz="2700" b="1" i="0">
+                <a:solidFill>
+                  <a:srgbClr val="2B2320"/>
+                </a:solidFill>
+                <a:latin typeface="Cambria"/>
+              </a:rPr>
+              <a:t>Colour Psychology and Cultural Meaning</a:t>
+            </a:r>
+          </a:p>
+        </p:txBody>
+      </p:sp>
+      <p:sp>
+        <p:nvSpPr>
+          <p:cNvPr id="4" name="Rounded Rectangle 3"/>
+          <p:cNvSpPr/>
+          <p:nvPr/>
+        </p:nvSpPr>
+        <p:spPr>
+          <a:xfrm>
+            <a:off x="685800" y="1874519"/>
+            <a:ext cx="10607040" cy="4526280"/>
+          </a:xfrm>
+          <a:prstGeom prst="roundRect">
+            <a:avLst>
+              <a:gd name="adj" fmla="val 6000"/>
+            </a:avLst>
+          </a:prstGeom>
+          <a:solidFill>
+            <a:srgbClr val="E8F0F0"/>
+          </a:solidFill>
+          <a:ln>
+            <a:noFill/>
+          </a:ln>
+          <a:effectLst/>
+        </p:spPr>
+        <p:style>
+          <a:lnRef idx="1">
+            <a:schemeClr val="accent1"/>
+          </a:lnRef>
+          <a:fillRef idx="3">
+            <a:schemeClr val="accent1"/>
+          </a:fillRef>
+          <a:effectRef idx="2">
+            <a:schemeClr val="accent1"/>
+          </a:effectRef>
+          <a:fontRef idx="minor">
+            <a:schemeClr val="lt1"/>
+          </a:fontRef>
+        </p:style>
+        <p:txBody>
+          <a:bodyPr rtlCol="0" anchor="ctr" lIns="330200" rIns="330200" tIns="254000" bIns="254000" wrap="square"/>
+          <a:lstStyle/>
+          <a:p>
+            <a:pPr algn="ctr" indent="-203200" marL="203200">
+              <a:spcAft>
+                <a:spcPts val="900"/>
+              </a:spcAft>
+              <a:buClr>
+                <a:srgbClr val="1F6F6B"/>
+              </a:buClr>
+              <a:buSzPct val="90000"/>
+              <a:buFont typeface="Arial"/>
+              <a:buChar char="●"/>
+            </a:pPr>
+            <a:r>
+              <a:rPr sz="1500" b="1" i="0">
+                <a:solidFill>
+                  <a:srgbClr val="1A5E5A"/>
+                </a:solidFill>
+                <a:latin typeface="Calibri"/>
+              </a:rPr>
+              <a:t>Psychological associations</a:t>
+            </a:r>
+          </a:p>
+          <a:p>
+            <a:pPr indent="-203200" marL="203200">
+              <a:spcAft>
+                <a:spcPts val="900"/>
+              </a:spcAft>
+              <a:buClr>
+                <a:srgbClr val="1F6F6B"/>
+              </a:buClr>
+              <a:buSzPct val="90000"/>
+              <a:buFont typeface="Arial"/>
+              <a:buChar char="–"/>
+            </a:pPr>
+            <a:r>
+              <a:rPr sz="1350" b="0" i="0">
+                <a:solidFill>
+                  <a:srgbClr val="2B2320"/>
+                </a:solidFill>
+                <a:latin typeface="Calibri"/>
+              </a:rPr>
+              <a:t>Red — urgency, passion, appetite, danger</a:t>
+            </a:r>
+          </a:p>
+          <a:p>
+            <a:pPr indent="-203200" marL="203200">
+              <a:spcAft>
+                <a:spcPts val="900"/>
+              </a:spcAft>
+              <a:buClr>
+                <a:srgbClr val="1F6F6B"/>
+              </a:buClr>
+              <a:buSzPct val="90000"/>
+              <a:buFont typeface="Arial"/>
+              <a:buChar char="–"/>
+            </a:pPr>
+            <a:r>
+              <a:rPr sz="1350" b="0" i="0">
+                <a:solidFill>
+                  <a:srgbClr val="2B2320"/>
+                </a:solidFill>
+                <a:latin typeface="Calibri"/>
+              </a:rPr>
+              <a:t>Blue — trust, calm, corporate stability</a:t>
+            </a:r>
+          </a:p>
+          <a:p>
+            <a:pPr indent="-203200" marL="203200">
+              <a:spcAft>
+                <a:spcPts val="900"/>
+              </a:spcAft>
+              <a:buClr>
+                <a:srgbClr val="1F6F6B"/>
+              </a:buClr>
+              <a:buSzPct val="90000"/>
+              <a:buFont typeface="Arial"/>
+              <a:buChar char="–"/>
+            </a:pPr>
+            <a:r>
+              <a:rPr sz="1350" b="0" i="0">
+                <a:solidFill>
+                  <a:srgbClr val="2B2320"/>
+                </a:solidFill>
+                <a:latin typeface="Calibri"/>
+              </a:rPr>
+              <a:t>Yellow — optimism, caution, attention-grabbing</a:t>
+            </a:r>
+          </a:p>
+          <a:p>
+            <a:pPr indent="-203200" marL="203200">
+              <a:spcAft>
+                <a:spcPts val="900"/>
+              </a:spcAft>
+              <a:buClr>
+                <a:srgbClr val="1F6F6B"/>
+              </a:buClr>
+              <a:buSzPct val="90000"/>
+              <a:buFont typeface="Arial"/>
+              <a:buChar char="–"/>
+            </a:pPr>
+            <a:r>
+              <a:rPr sz="1350" b="0" i="0">
+                <a:solidFill>
+                  <a:srgbClr val="2B2320"/>
+                </a:solidFill>
+                <a:latin typeface="Calibri"/>
+              </a:rPr>
+              <a:t>Green — growth, health, sustainability</a:t>
+            </a:r>
+          </a:p>
+          <a:p>
+            <a:pPr indent="-203200" marL="203200">
+              <a:spcAft>
+                <a:spcPts val="900"/>
+              </a:spcAft>
+              <a:buClr>
+                <a:srgbClr val="1F6F6B"/>
+              </a:buClr>
+              <a:buSzPct val="90000"/>
+              <a:buFont typeface="Arial"/>
+              <a:buChar char="–"/>
+            </a:pPr>
+            <a:r>
+              <a:rPr sz="1350" b="0" i="0">
+                <a:solidFill>
+                  <a:srgbClr val="2B2320"/>
+                </a:solidFill>
+                <a:latin typeface="Calibri"/>
+              </a:rPr>
+              <a:t>Black — luxury, sophistication, or mourning depending on context</a:t>
+            </a:r>
+          </a:p>
+          <a:p>
+            <a:pPr indent="-203200" marL="203200">
+              <a:spcAft>
+                <a:spcPts val="900"/>
+              </a:spcAft>
+              <a:buClr>
+                <a:srgbClr val="1F6F6B"/>
+              </a:buClr>
+              <a:buSzPct val="90000"/>
+              <a:buFont typeface="Arial"/>
+              <a:buChar char="●"/>
+            </a:pPr>
+            <a:r>
+              <a:rPr sz="1500" b="1" i="0">
+                <a:solidFill>
+                  <a:srgbClr val="1A5E5A"/>
+                </a:solidFill>
+                <a:latin typeface="Calibri"/>
+              </a:rPr>
+              <a:t>Cultural variation</a:t>
+            </a:r>
+          </a:p>
+          <a:p>
+            <a:pPr indent="-203200" marL="203200">
+              <a:spcAft>
+                <a:spcPts val="900"/>
+              </a:spcAft>
+              <a:buClr>
+                <a:srgbClr val="1F6F6B"/>
+              </a:buClr>
+              <a:buSzPct val="90000"/>
+              <a:buFont typeface="Arial"/>
+              <a:buChar char="–"/>
+            </a:pPr>
+            <a:r>
+              <a:rPr sz="1350" b="0" i="0">
+                <a:solidFill>
+                  <a:srgbClr val="2B2320"/>
+                </a:solidFill>
+                <a:latin typeface="Calibri"/>
+              </a:rPr>
+              <a:t>Colour meaning is not universal. White signals purity and weddings in many Western contexts but mourning in parts of East Asia. Red is associated with luck and celebration in Chinese culture but can signal danger elsewhere. Always consider a design's target market and cultural context before assuming a colour's meaning is fixed.</a:t>
+            </a:r>
+          </a:p>
+          <a:p>
+            <a:pPr indent="-203200" marL="203200">
+              <a:spcAft>
+                <a:spcPts val="900"/>
+              </a:spcAft>
+              <a:buClr>
+                <a:srgbClr val="1F6F6B"/>
+              </a:buClr>
+              <a:buSzPct val="90000"/>
+              <a:buFont typeface="Arial"/>
+              <a:buChar char="●"/>
+            </a:pPr>
+            <a:r>
+              <a:rPr sz="1500" b="1" i="0">
+                <a:solidFill>
+                  <a:srgbClr val="1A5E5A"/>
+                </a:solidFill>
+                <a:latin typeface="Calibri"/>
+              </a:rPr>
+              <a:t>Colour accessibility</a:t>
+            </a:r>
+          </a:p>
+          <a:p>
+            <a:pPr indent="-203200" marL="203200">
+              <a:spcAft>
+                <a:spcPts val="900"/>
+              </a:spcAft>
+              <a:buClr>
+                <a:srgbClr val="1F6F6B"/>
+              </a:buClr>
+              <a:buSzPct val="90000"/>
+              <a:buFont typeface="Arial"/>
+              <a:buChar char="–"/>
+            </a:pPr>
+            <a:r>
+              <a:rPr sz="1350" b="0" i="0">
+                <a:solidFill>
+                  <a:srgbClr val="2B2320"/>
+                </a:solidFill>
+                <a:latin typeface="Calibri"/>
+              </a:rPr>
+              <a:t>Approximately 1 in 12 men and 1 in 200 women have some form of colour vision deficiency</a:t>
+            </a:r>
+          </a:p>
+          <a:p>
+            <a:pPr indent="-203200" marL="203200">
+              <a:spcAft>
+                <a:spcPts val="900"/>
+              </a:spcAft>
+              <a:buClr>
+                <a:srgbClr val="1F6F6B"/>
+              </a:buClr>
+              <a:buSzPct val="90000"/>
+              <a:buFont typeface="Arial"/>
+              <a:buChar char="–"/>
+            </a:pPr>
+            <a:r>
+              <a:rPr sz="1350" b="0" i="0">
+                <a:solidFill>
+                  <a:srgbClr val="2B2320"/>
+                </a:solidFill>
+                <a:latin typeface="Calibri"/>
+              </a:rPr>
+              <a:t>Never rely on colour alone to convey information — pair colour with text, icons or patterns</a:t>
+            </a:r>
+          </a:p>
+          <a:p>
+            <a:pPr indent="-203200" marL="203200">
+              <a:spcAft>
+                <a:spcPts val="900"/>
+              </a:spcAft>
+              <a:buClr>
+                <a:srgbClr val="1F6F6B"/>
+              </a:buClr>
+              <a:buSzPct val="90000"/>
+              <a:buFont typeface="Arial"/>
+              <a:buChar char="–"/>
+            </a:pPr>
+            <a:r>
+              <a:rPr sz="1350" b="0" i="0">
+                <a:solidFill>
+                  <a:srgbClr val="2B2320"/>
+                </a:solidFill>
+                <a:latin typeface="Calibri"/>
+              </a:rPr>
+              <a:t>Check contrast ratios for text on coloured backgrounds (WCAG guidelines recommend a minimum contrast ratio of 4.5:1 for standard body text)</a:t>
+            </a:r>
+          </a:p>
+        </p:txBody>
+      </p:sp>
+      <p:sp>
+        <p:nvSpPr>
+          <p:cNvPr id="5" name="Oval 4"/>
+          <p:cNvSpPr/>
+          <p:nvPr/>
+        </p:nvSpPr>
+        <p:spPr>
+          <a:xfrm>
+            <a:off x="10881360" y="5943600"/>
+            <a:ext cx="1005840" cy="1005840"/>
+          </a:xfrm>
+          <a:prstGeom prst="ellipse">
+            <a:avLst/>
+          </a:prstGeom>
+          <a:solidFill>
+            <a:srgbClr val="F4B8C3"/>
+          </a:solidFill>
+          <a:ln>
+            <a:noFill/>
+          </a:ln>
+          <a:effectLst/>
+        </p:spPr>
+        <p:style>
+          <a:lnRef idx="1">
+            <a:schemeClr val="accent1"/>
+          </a:lnRef>
+          <a:fillRef idx="3">
+            <a:schemeClr val="accent1"/>
+          </a:fillRef>
+          <a:effectRef idx="2">
+            <a:schemeClr val="accent1"/>
+          </a:effectRef>
+          <a:fontRef idx="minor">
+            <a:schemeClr val="lt1"/>
+          </a:fontRef>
+        </p:style>
+        <p:txBody>
+          <a:bodyPr rtlCol="0" anchor="ctr"/>
+          <a:lstStyle/>
+          <a:p>
+            <a:pPr algn="ctr"/>
+          </a:p>
+        </p:txBody>
+      </p:sp>
+    </p:spTree>
+  </p:cSld>
+  <p:clrMapOvr>
+    <a:masterClrMapping/>
+  </p:clrMapOvr>
+</p:sld>
+</file>
+
+<file path=ppt/slides/slide62.xml><?xml version="1.0" encoding="utf-8"?>
+<p:sld xmlns:a="http://schemas.openxmlformats.org/drawingml/2006/main" xmlns:p="http://schemas.openxmlformats.org/presentationml/2006/main" xmlns:r="http://schemas.openxmlformats.org/officeDocument/2006/relationships">
+  <p:cSld>
+    <p:bg>
+      <p:bgPr>
+        <a:solidFill>
+          <a:srgbClr val="FCF8F1"/>
+        </a:solidFill>
+        <a:effectLst/>
+      </p:bgPr>
+    </p:bg>
+    <p:spTree>
+      <p:nvGrpSpPr>
+        <p:cNvPr id="1" name=""/>
+        <p:cNvGrpSpPr/>
+        <p:nvPr/>
+      </p:nvGrpSpPr>
+      <p:grpSpPr/>
+      <p:sp>
+        <p:nvSpPr>
+          <p:cNvPr id="2" name="Rounded Rectangle 1"/>
+          <p:cNvSpPr/>
+          <p:nvPr/>
+        </p:nvSpPr>
+        <p:spPr>
+          <a:xfrm>
+            <a:off x="685800" y="502920"/>
+            <a:ext cx="3291840" cy="457200"/>
+          </a:xfrm>
+          <a:prstGeom prst="roundRect">
+            <a:avLst>
+              <a:gd name="adj" fmla="val 50000"/>
+            </a:avLst>
+          </a:prstGeom>
+          <a:solidFill>
+            <a:srgbClr val="1F6F6B"/>
+          </a:solidFill>
+          <a:ln>
+            <a:noFill/>
+          </a:ln>
+          <a:effectLst/>
+        </p:spPr>
+        <p:style>
+          <a:lnRef idx="1">
+            <a:schemeClr val="accent1"/>
+          </a:lnRef>
+          <a:fillRef idx="3">
+            <a:schemeClr val="accent1"/>
+          </a:fillRef>
+          <a:effectRef idx="2">
+            <a:schemeClr val="accent1"/>
+          </a:effectRef>
+          <a:fontRef idx="minor">
+            <a:schemeClr val="lt1"/>
+          </a:fontRef>
+        </p:style>
+        <p:txBody>
+          <a:bodyPr rtlCol="0" anchor="ctr" wrap="none" lIns="50800" rIns="50800"/>
+          <a:lstStyle/>
+          <a:p>
+            <a:pPr algn="ctr"/>
+            <a:r>
+              <a:rPr sz="1100" b="1">
+                <a:solidFill>
+                  <a:srgbClr val="FFFFFF"/>
+                </a:solidFill>
+                <a:latin typeface="Calibri"/>
+              </a:rPr>
+              <a:t>EXTENDED KNOWLEDGE</a:t>
+            </a:r>
+          </a:p>
+        </p:txBody>
+      </p:sp>
+      <p:sp>
+        <p:nvSpPr>
+          <p:cNvPr id="3" name="TextBox 2"/>
+          <p:cNvSpPr txBox="1"/>
+          <p:nvPr/>
+        </p:nvSpPr>
+        <p:spPr>
+          <a:xfrm>
+            <a:off x="685800" y="1051560"/>
+            <a:ext cx="10607040" cy="822960"/>
+          </a:xfrm>
+          <a:prstGeom prst="rect">
+            <a:avLst/>
+          </a:prstGeom>
+          <a:noFill/>
+        </p:spPr>
+        <p:txBody>
+          <a:bodyPr wrap="square" anchor="t">
+            <a:spAutoFit/>
+          </a:bodyPr>
+          <a:lstStyle/>
+          <a:p>
+            <a:pPr algn="l"/>
+            <a:r>
+              <a:rPr sz="2700" b="1" i="0">
+                <a:solidFill>
+                  <a:srgbClr val="2B2320"/>
+                </a:solidFill>
+                <a:latin typeface="Cambria"/>
+              </a:rPr>
+              <a:t>Visual Perception Beyond the VCAA Gestalt Principles</a:t>
+            </a:r>
+          </a:p>
+        </p:txBody>
+      </p:sp>
+      <p:sp>
+        <p:nvSpPr>
+          <p:cNvPr id="4" name="Rounded Rectangle 3"/>
+          <p:cNvSpPr/>
+          <p:nvPr/>
+        </p:nvSpPr>
+        <p:spPr>
+          <a:xfrm>
+            <a:off x="685800" y="1874519"/>
+            <a:ext cx="10607040" cy="4526280"/>
+          </a:xfrm>
+          <a:prstGeom prst="roundRect">
+            <a:avLst>
+              <a:gd name="adj" fmla="val 6000"/>
+            </a:avLst>
+          </a:prstGeom>
+          <a:solidFill>
+            <a:srgbClr val="E8F0F0"/>
+          </a:solidFill>
+          <a:ln>
+            <a:noFill/>
+          </a:ln>
+          <a:effectLst/>
+        </p:spPr>
+        <p:style>
+          <a:lnRef idx="1">
+            <a:schemeClr val="accent1"/>
+          </a:lnRef>
+          <a:fillRef idx="3">
+            <a:schemeClr val="accent1"/>
+          </a:fillRef>
+          <a:effectRef idx="2">
+            <a:schemeClr val="accent1"/>
+          </a:effectRef>
+          <a:fontRef idx="minor">
+            <a:schemeClr val="lt1"/>
+          </a:fontRef>
+        </p:style>
+        <p:txBody>
+          <a:bodyPr rtlCol="0" anchor="ctr" lIns="330200" rIns="330200" tIns="254000" bIns="254000" wrap="square"/>
+          <a:lstStyle/>
+          <a:p>
+            <a:pPr algn="ctr" indent="-203200" marL="203200">
+              <a:spcAft>
+                <a:spcPts val="900"/>
+              </a:spcAft>
+              <a:buClr>
+                <a:srgbClr val="1F6F6B"/>
+              </a:buClr>
+              <a:buSzPct val="90000"/>
+              <a:buFont typeface="Arial"/>
+              <a:buChar char="●"/>
+            </a:pPr>
+            <a:r>
+              <a:rPr sz="1500" b="1" i="0">
+                <a:solidFill>
+                  <a:srgbClr val="1A5E5A"/>
+                </a:solidFill>
+                <a:latin typeface="Calibri"/>
+              </a:rPr>
+              <a:t>Origins of Gestalt psychology</a:t>
+            </a:r>
+          </a:p>
+          <a:p>
+            <a:pPr indent="-203200" marL="203200">
+              <a:spcAft>
+                <a:spcPts val="900"/>
+              </a:spcAft>
+              <a:buClr>
+                <a:srgbClr val="1F6F6B"/>
+              </a:buClr>
+              <a:buSzPct val="90000"/>
+              <a:buFont typeface="Arial"/>
+              <a:buChar char="–"/>
+            </a:pPr>
+            <a:r>
+              <a:rPr sz="1350" b="0" i="0">
+                <a:solidFill>
+                  <a:srgbClr val="2B2320"/>
+                </a:solidFill>
+                <a:latin typeface="Calibri"/>
+              </a:rPr>
+              <a:t>Gestalt theory originated with German psychologists Max Wertheimer, Kurt Koffka and Wolfgang Köhler in the early 20th century, who argued the mind perceives whole patterns and configurations rather than isolated parts — summarised by the phrase 'the whole is greater than the sum of its parts'.</a:t>
+            </a:r>
+          </a:p>
+          <a:p>
+            <a:pPr indent="-203200" marL="203200">
+              <a:spcAft>
+                <a:spcPts val="900"/>
+              </a:spcAft>
+              <a:buClr>
+                <a:srgbClr val="1F6F6B"/>
+              </a:buClr>
+              <a:buSzPct val="90000"/>
+              <a:buFont typeface="Arial"/>
+              <a:buChar char="●"/>
+            </a:pPr>
+            <a:r>
+              <a:rPr sz="1500" b="1" i="0">
+                <a:solidFill>
+                  <a:srgbClr val="1A5E5A"/>
+                </a:solidFill>
+                <a:latin typeface="Calibri"/>
+              </a:rPr>
+              <a:t>Related principles worth knowing (not VCAA-examinable)</a:t>
+            </a:r>
+          </a:p>
+          <a:p>
+            <a:pPr indent="-203200" marL="203200">
+              <a:spcAft>
+                <a:spcPts val="900"/>
+              </a:spcAft>
+              <a:buClr>
+                <a:srgbClr val="1F6F6B"/>
+              </a:buClr>
+              <a:buSzPct val="90000"/>
+              <a:buFont typeface="Arial"/>
+              <a:buChar char="–"/>
+            </a:pPr>
+            <a:r>
+              <a:rPr sz="1350" b="0" i="0">
+                <a:solidFill>
+                  <a:srgbClr val="2B2320"/>
+                </a:solidFill>
+                <a:latin typeface="Calibri"/>
+              </a:rPr>
+              <a:t>Common Fate — elements moving in the same direction are perceived as a group</a:t>
+            </a:r>
+          </a:p>
+          <a:p>
+            <a:pPr indent="-203200" marL="203200">
+              <a:spcAft>
+                <a:spcPts val="900"/>
+              </a:spcAft>
+              <a:buClr>
+                <a:srgbClr val="1F6F6B"/>
+              </a:buClr>
+              <a:buSzPct val="90000"/>
+              <a:buFont typeface="Arial"/>
+              <a:buChar char="–"/>
+            </a:pPr>
+            <a:r>
+              <a:rPr sz="1350" b="0" i="0">
+                <a:solidFill>
+                  <a:srgbClr val="2B2320"/>
+                </a:solidFill>
+                <a:latin typeface="Calibri"/>
+              </a:rPr>
+              <a:t>Symmetry — symmetrical elements are perceived as belonging together, even across a distance</a:t>
+            </a:r>
+          </a:p>
+          <a:p>
+            <a:pPr indent="-203200" marL="203200">
+              <a:spcAft>
+                <a:spcPts val="900"/>
+              </a:spcAft>
+              <a:buClr>
+                <a:srgbClr val="1F6F6B"/>
+              </a:buClr>
+              <a:buSzPct val="90000"/>
+              <a:buFont typeface="Arial"/>
+              <a:buChar char="–"/>
+            </a:pPr>
+            <a:r>
+              <a:rPr sz="1350" b="0" i="0">
+                <a:solidFill>
+                  <a:srgbClr val="2B2320"/>
+                </a:solidFill>
+                <a:latin typeface="Calibri"/>
+              </a:rPr>
+              <a:t>Common Region — elements sharing an enclosed area are perceived as grouped</a:t>
+            </a:r>
+          </a:p>
+        </p:txBody>
+      </p:sp>
+      <p:sp>
+        <p:nvSpPr>
+          <p:cNvPr id="5" name="Oval 4"/>
+          <p:cNvSpPr/>
+          <p:nvPr/>
+        </p:nvSpPr>
+        <p:spPr>
+          <a:xfrm>
+            <a:off x="10881360" y="5943600"/>
+            <a:ext cx="1005840" cy="1005840"/>
+          </a:xfrm>
+          <a:prstGeom prst="ellipse">
+            <a:avLst/>
+          </a:prstGeom>
+          <a:solidFill>
+            <a:srgbClr val="F4B8C3"/>
+          </a:solidFill>
+          <a:ln>
+            <a:noFill/>
+          </a:ln>
+          <a:effectLst/>
+        </p:spPr>
+        <p:style>
+          <a:lnRef idx="1">
+            <a:schemeClr val="accent1"/>
+          </a:lnRef>
+          <a:fillRef idx="3">
+            <a:schemeClr val="accent1"/>
+          </a:fillRef>
+          <a:effectRef idx="2">
+            <a:schemeClr val="accent1"/>
+          </a:effectRef>
+          <a:fontRef idx="minor">
+            <a:schemeClr val="lt1"/>
+          </a:fontRef>
+        </p:style>
+        <p:txBody>
+          <a:bodyPr rtlCol="0" anchor="ctr"/>
+          <a:lstStyle/>
+          <a:p>
+            <a:pPr algn="ctr"/>
+          </a:p>
+        </p:txBody>
+      </p:sp>
+    </p:spTree>
+  </p:cSld>
+  <p:clrMapOvr>
+    <a:masterClrMapping/>
+  </p:clrMapOvr>
+</p:sld>
+</file>
+
+<file path=ppt/slides/slide63.xml><?xml version="1.0" encoding="utf-8"?>
+<p:sld xmlns:a="http://schemas.openxmlformats.org/drawingml/2006/main" xmlns:p="http://schemas.openxmlformats.org/presentationml/2006/main" xmlns:r="http://schemas.openxmlformats.org/officeDocument/2006/relationships">
+  <p:cSld>
+    <p:bg>
+      <p:bgPr>
+        <a:solidFill>
+          <a:srgbClr val="FCF8F1"/>
+        </a:solidFill>
+        <a:effectLst/>
+      </p:bgPr>
+    </p:bg>
+    <p:spTree>
+      <p:nvGrpSpPr>
+        <p:cNvPr id="1" name=""/>
+        <p:cNvGrpSpPr/>
+        <p:nvPr/>
+      </p:nvGrpSpPr>
+      <p:grpSpPr/>
+      <p:sp>
+        <p:nvSpPr>
+          <p:cNvPr id="2" name="Rounded Rectangle 1"/>
+          <p:cNvSpPr/>
+          <p:nvPr/>
+        </p:nvSpPr>
+        <p:spPr>
+          <a:xfrm>
+            <a:off x="685800" y="502920"/>
+            <a:ext cx="3291840" cy="457200"/>
+          </a:xfrm>
+          <a:prstGeom prst="roundRect">
+            <a:avLst>
+              <a:gd name="adj" fmla="val 50000"/>
+            </a:avLst>
+          </a:prstGeom>
+          <a:solidFill>
+            <a:srgbClr val="1F6F6B"/>
+          </a:solidFill>
+          <a:ln>
+            <a:noFill/>
+          </a:ln>
+          <a:effectLst/>
+        </p:spPr>
+        <p:style>
+          <a:lnRef idx="1">
+            <a:schemeClr val="accent1"/>
+          </a:lnRef>
+          <a:fillRef idx="3">
+            <a:schemeClr val="accent1"/>
+          </a:fillRef>
+          <a:effectRef idx="2">
+            <a:schemeClr val="accent1"/>
+          </a:effectRef>
+          <a:fontRef idx="minor">
+            <a:schemeClr val="lt1"/>
+          </a:fontRef>
+        </p:style>
+        <p:txBody>
+          <a:bodyPr rtlCol="0" anchor="ctr" wrap="none" lIns="50800" rIns="50800"/>
+          <a:lstStyle/>
+          <a:p>
+            <a:pPr algn="ctr"/>
+            <a:r>
+              <a:rPr sz="1100" b="1">
+                <a:solidFill>
+                  <a:srgbClr val="FFFFFF"/>
+                </a:solidFill>
+                <a:latin typeface="Calibri"/>
+              </a:rPr>
+              <a:t>EXTENDED KNOWLEDGE</a:t>
+            </a:r>
+          </a:p>
+        </p:txBody>
+      </p:sp>
+      <p:sp>
+        <p:nvSpPr>
+          <p:cNvPr id="3" name="TextBox 2"/>
+          <p:cNvSpPr txBox="1"/>
+          <p:nvPr/>
+        </p:nvSpPr>
+        <p:spPr>
+          <a:xfrm>
+            <a:off x="685800" y="1051560"/>
+            <a:ext cx="10607040" cy="822960"/>
+          </a:xfrm>
+          <a:prstGeom prst="rect">
+            <a:avLst/>
+          </a:prstGeom>
+          <a:noFill/>
+        </p:spPr>
+        <p:txBody>
+          <a:bodyPr wrap="square" anchor="t">
+            <a:spAutoFit/>
+          </a:bodyPr>
+          <a:lstStyle/>
+          <a:p>
+            <a:pPr algn="l"/>
+            <a:r>
+              <a:rPr sz="2700" b="1" i="0">
+                <a:solidFill>
+                  <a:srgbClr val="2B2320"/>
+                </a:solidFill>
+                <a:latin typeface="Cambria"/>
+              </a:rPr>
+              <a:t>Typography Deep Dive</a:t>
+            </a:r>
+          </a:p>
+        </p:txBody>
+      </p:sp>
+      <p:sp>
+        <p:nvSpPr>
+          <p:cNvPr id="4" name="Rounded Rectangle 3"/>
+          <p:cNvSpPr/>
+          <p:nvPr/>
+        </p:nvSpPr>
+        <p:spPr>
+          <a:xfrm>
+            <a:off x="685800" y="1874519"/>
+            <a:ext cx="10607040" cy="4526280"/>
+          </a:xfrm>
+          <a:prstGeom prst="roundRect">
+            <a:avLst>
+              <a:gd name="adj" fmla="val 6000"/>
+            </a:avLst>
+          </a:prstGeom>
+          <a:solidFill>
+            <a:srgbClr val="E8F0F0"/>
+          </a:solidFill>
+          <a:ln>
+            <a:noFill/>
+          </a:ln>
+          <a:effectLst/>
+        </p:spPr>
+        <p:style>
+          <a:lnRef idx="1">
+            <a:schemeClr val="accent1"/>
+          </a:lnRef>
+          <a:fillRef idx="3">
+            <a:schemeClr val="accent1"/>
+          </a:fillRef>
+          <a:effectRef idx="2">
+            <a:schemeClr val="accent1"/>
+          </a:effectRef>
+          <a:fontRef idx="minor">
+            <a:schemeClr val="lt1"/>
+          </a:fontRef>
+        </p:style>
+        <p:txBody>
+          <a:bodyPr rtlCol="0" anchor="ctr" lIns="330200" rIns="330200" tIns="254000" bIns="254000" wrap="square"/>
+          <a:lstStyle/>
+          <a:p>
+            <a:pPr algn="ctr" indent="-203200" marL="203200">
+              <a:spcAft>
+                <a:spcPts val="900"/>
+              </a:spcAft>
+              <a:buClr>
+                <a:srgbClr val="1F6F6B"/>
+              </a:buClr>
+              <a:buSzPct val="90000"/>
+              <a:buFont typeface="Arial"/>
+              <a:buChar char="●"/>
+            </a:pPr>
+            <a:r>
+              <a:rPr sz="1500" b="1" i="0">
+                <a:solidFill>
+                  <a:srgbClr val="1A5E5A"/>
+                </a:solidFill>
+                <a:latin typeface="Calibri"/>
+              </a:rPr>
+              <a:t>Legibility vs readability</a:t>
+            </a:r>
+          </a:p>
+          <a:p>
+            <a:pPr indent="-203200" marL="203200">
+              <a:spcAft>
+                <a:spcPts val="900"/>
+              </a:spcAft>
+              <a:buClr>
+                <a:srgbClr val="1F6F6B"/>
+              </a:buClr>
+              <a:buSzPct val="90000"/>
+              <a:buFont typeface="Arial"/>
+              <a:buChar char="–"/>
+            </a:pPr>
+            <a:r>
+              <a:rPr sz="1350" b="0" i="0">
+                <a:solidFill>
+                  <a:srgbClr val="2B2320"/>
+                </a:solidFill>
+                <a:latin typeface="Calibri"/>
+              </a:rPr>
+              <a:t>Legibility is about how easily individual letterforms can be distinguished from each other. Readability is about how easily a whole passage of text can be read — affected by line length, leading, and spacing, not just typeface choice.</a:t>
+            </a:r>
+          </a:p>
+          <a:p>
+            <a:pPr indent="-203200" marL="203200">
+              <a:spcAft>
+                <a:spcPts val="900"/>
+              </a:spcAft>
+              <a:buClr>
+                <a:srgbClr val="1F6F6B"/>
+              </a:buClr>
+              <a:buSzPct val="90000"/>
+              <a:buFont typeface="Arial"/>
+              <a:buChar char="●"/>
+            </a:pPr>
+            <a:r>
+              <a:rPr sz="1500" b="1" i="0">
+                <a:solidFill>
+                  <a:srgbClr val="1A5E5A"/>
+                </a:solidFill>
+                <a:latin typeface="Calibri"/>
+              </a:rPr>
+              <a:t>Type pairing</a:t>
+            </a:r>
+          </a:p>
+          <a:p>
+            <a:pPr indent="-203200" marL="203200">
+              <a:spcAft>
+                <a:spcPts val="900"/>
+              </a:spcAft>
+              <a:buClr>
+                <a:srgbClr val="1F6F6B"/>
+              </a:buClr>
+              <a:buSzPct val="90000"/>
+              <a:buFont typeface="Arial"/>
+              <a:buChar char="–"/>
+            </a:pPr>
+            <a:r>
+              <a:rPr sz="1350" b="0" i="0">
+                <a:solidFill>
+                  <a:srgbClr val="2B2320"/>
+                </a:solidFill>
+                <a:latin typeface="Calibri"/>
+              </a:rPr>
+              <a:t>Pair typefaces with contrasting roles, e.g. a bold serif display face with a clean sans body face</a:t>
+            </a:r>
+          </a:p>
+          <a:p>
+            <a:pPr indent="-203200" marL="203200">
+              <a:spcAft>
+                <a:spcPts val="900"/>
+              </a:spcAft>
+              <a:buClr>
+                <a:srgbClr val="1F6F6B"/>
+              </a:buClr>
+              <a:buSzPct val="90000"/>
+              <a:buFont typeface="Arial"/>
+              <a:buChar char="–"/>
+            </a:pPr>
+            <a:r>
+              <a:rPr sz="1350" b="0" i="0">
+                <a:solidFill>
+                  <a:srgbClr val="2B2320"/>
+                </a:solidFill>
+                <a:latin typeface="Calibri"/>
+              </a:rPr>
+              <a:t>Limit a design to 2-3 typefaces to avoid visual clutter</a:t>
+            </a:r>
+          </a:p>
+          <a:p>
+            <a:pPr indent="-203200" marL="203200">
+              <a:spcAft>
+                <a:spcPts val="900"/>
+              </a:spcAft>
+              <a:buClr>
+                <a:srgbClr val="1F6F6B"/>
+              </a:buClr>
+              <a:buSzPct val="90000"/>
+              <a:buFont typeface="Arial"/>
+              <a:buChar char="–"/>
+            </a:pPr>
+            <a:r>
+              <a:rPr sz="1350" b="0" i="0">
+                <a:solidFill>
+                  <a:srgbClr val="2B2320"/>
+                </a:solidFill>
+                <a:latin typeface="Calibri"/>
+              </a:rPr>
+              <a:t>Superfamilies (e.g. a typeface with matching serif, sans and mono versions) pair reliably because they share proportions</a:t>
+            </a:r>
+          </a:p>
+          <a:p>
+            <a:pPr indent="-203200" marL="203200">
+              <a:spcAft>
+                <a:spcPts val="900"/>
+              </a:spcAft>
+              <a:buClr>
+                <a:srgbClr val="1F6F6B"/>
+              </a:buClr>
+              <a:buSzPct val="90000"/>
+              <a:buFont typeface="Arial"/>
+              <a:buChar char="●"/>
+            </a:pPr>
+            <a:r>
+              <a:rPr sz="1500" b="1" i="0">
+                <a:solidFill>
+                  <a:srgbClr val="1A5E5A"/>
+                </a:solidFill>
+                <a:latin typeface="Calibri"/>
+              </a:rPr>
+              <a:t>A brief history of key typefaces</a:t>
+            </a:r>
+          </a:p>
+          <a:p>
+            <a:pPr indent="-203200" marL="203200">
+              <a:spcAft>
+                <a:spcPts val="900"/>
+              </a:spcAft>
+              <a:buClr>
+                <a:srgbClr val="1F6F6B"/>
+              </a:buClr>
+              <a:buSzPct val="90000"/>
+              <a:buFont typeface="Arial"/>
+              <a:buChar char="–"/>
+            </a:pPr>
+            <a:r>
+              <a:rPr sz="1350" b="0" i="0">
+                <a:solidFill>
+                  <a:srgbClr val="2B2320"/>
+                </a:solidFill>
+                <a:latin typeface="Calibri"/>
+              </a:rPr>
+              <a:t>Garamond (16th century) — classic old-style serif, still used in book typesetting</a:t>
+            </a:r>
+          </a:p>
+          <a:p>
+            <a:pPr indent="-203200" marL="203200">
+              <a:spcAft>
+                <a:spcPts val="900"/>
+              </a:spcAft>
+              <a:buClr>
+                <a:srgbClr val="1F6F6B"/>
+              </a:buClr>
+              <a:buSzPct val="90000"/>
+              <a:buFont typeface="Arial"/>
+              <a:buChar char="–"/>
+            </a:pPr>
+            <a:r>
+              <a:rPr sz="1350" b="0" i="0">
+                <a:solidFill>
+                  <a:srgbClr val="2B2320"/>
+                </a:solidFill>
+                <a:latin typeface="Calibri"/>
+              </a:rPr>
+              <a:t>Gill Sans (1928) — British humanist sans-serif</a:t>
+            </a:r>
+          </a:p>
+          <a:p>
+            <a:pPr indent="-203200" marL="203200">
+              <a:spcAft>
+                <a:spcPts val="900"/>
+              </a:spcAft>
+              <a:buClr>
+                <a:srgbClr val="1F6F6B"/>
+              </a:buClr>
+              <a:buSzPct val="90000"/>
+              <a:buFont typeface="Arial"/>
+              <a:buChar char="–"/>
+            </a:pPr>
+            <a:r>
+              <a:rPr sz="1350" b="0" i="0">
+                <a:solidFill>
+                  <a:srgbClr val="2B2320"/>
+                </a:solidFill>
+                <a:latin typeface="Calibri"/>
+              </a:rPr>
+              <a:t>Helvetica (1957) — Swiss neo-grotesque, symbol of the International Typographic Style</a:t>
+            </a:r>
+          </a:p>
+          <a:p>
+            <a:pPr indent="-203200" marL="203200">
+              <a:spcAft>
+                <a:spcPts val="900"/>
+              </a:spcAft>
+              <a:buClr>
+                <a:srgbClr val="1F6F6B"/>
+              </a:buClr>
+              <a:buSzPct val="90000"/>
+              <a:buFont typeface="Arial"/>
+              <a:buChar char="–"/>
+            </a:pPr>
+            <a:r>
+              <a:rPr sz="1350" b="0" i="0">
+                <a:solidFill>
+                  <a:srgbClr val="2B2320"/>
+                </a:solidFill>
+                <a:latin typeface="Calibri"/>
+              </a:rPr>
+              <a:t>Futura (1927) — geometric sans-serif based on circles, squares and triangles</a:t>
+            </a:r>
+          </a:p>
+        </p:txBody>
+      </p:sp>
+      <p:sp>
+        <p:nvSpPr>
+          <p:cNvPr id="5" name="Oval 4"/>
+          <p:cNvSpPr/>
+          <p:nvPr/>
+        </p:nvSpPr>
+        <p:spPr>
+          <a:xfrm>
+            <a:off x="10881360" y="5943600"/>
+            <a:ext cx="1005840" cy="1005840"/>
+          </a:xfrm>
+          <a:prstGeom prst="ellipse">
+            <a:avLst/>
+          </a:prstGeom>
+          <a:solidFill>
+            <a:srgbClr val="F4B8C3"/>
+          </a:solidFill>
+          <a:ln>
+            <a:noFill/>
+          </a:ln>
+          <a:effectLst/>
+        </p:spPr>
+        <p:style>
+          <a:lnRef idx="1">
+            <a:schemeClr val="accent1"/>
+          </a:lnRef>
+          <a:fillRef idx="3">
+            <a:schemeClr val="accent1"/>
+          </a:fillRef>
+          <a:effectRef idx="2">
+            <a:schemeClr val="accent1"/>
+          </a:effectRef>
+          <a:fontRef idx="minor">
+            <a:schemeClr val="lt1"/>
+          </a:fontRef>
+        </p:style>
+        <p:txBody>
+          <a:bodyPr rtlCol="0" anchor="ctr"/>
+          <a:lstStyle/>
+          <a:p>
+            <a:pPr algn="ctr"/>
+          </a:p>
+        </p:txBody>
+      </p:sp>
+    </p:spTree>
+  </p:cSld>
+  <p:clrMapOvr>
+    <a:masterClrMapping/>
+  </p:clrMapOvr>
+</p:sld>
+</file>
+
+<file path=ppt/slides/slide64.xml><?xml version="1.0" encoding="utf-8"?>
+<p:sld xmlns:a="http://schemas.openxmlformats.org/drawingml/2006/main" xmlns:p="http://schemas.openxmlformats.org/presentationml/2006/main" xmlns:r="http://schemas.openxmlformats.org/officeDocument/2006/relationships">
+  <p:cSld>
+    <p:bg>
+      <p:bgPr>
+        <a:solidFill>
+          <a:srgbClr val="FCF8F1"/>
+        </a:solidFill>
+        <a:effectLst/>
+      </p:bgPr>
+    </p:bg>
+    <p:spTree>
+      <p:nvGrpSpPr>
+        <p:cNvPr id="1" name=""/>
+        <p:cNvGrpSpPr/>
+        <p:nvPr/>
+      </p:nvGrpSpPr>
+      <p:grpSpPr/>
+      <p:sp>
+        <p:nvSpPr>
+          <p:cNvPr id="2" name="Rounded Rectangle 1"/>
+          <p:cNvSpPr/>
+          <p:nvPr/>
+        </p:nvSpPr>
+        <p:spPr>
+          <a:xfrm>
+            <a:off x="685800" y="502920"/>
+            <a:ext cx="3291840" cy="457200"/>
+          </a:xfrm>
+          <a:prstGeom prst="roundRect">
+            <a:avLst>
+              <a:gd name="adj" fmla="val 50000"/>
+            </a:avLst>
+          </a:prstGeom>
+          <a:solidFill>
+            <a:srgbClr val="1F6F6B"/>
+          </a:solidFill>
+          <a:ln>
+            <a:noFill/>
+          </a:ln>
+          <a:effectLst/>
+        </p:spPr>
+        <p:style>
+          <a:lnRef idx="1">
+            <a:schemeClr val="accent1"/>
+          </a:lnRef>
+          <a:fillRef idx="3">
+            <a:schemeClr val="accent1"/>
+          </a:fillRef>
+          <a:effectRef idx="2">
+            <a:schemeClr val="accent1"/>
+          </a:effectRef>
+          <a:fontRef idx="minor">
+            <a:schemeClr val="lt1"/>
+          </a:fontRef>
+        </p:style>
+        <p:txBody>
+          <a:bodyPr rtlCol="0" anchor="ctr" wrap="none" lIns="50800" rIns="50800"/>
+          <a:lstStyle/>
+          <a:p>
+            <a:pPr algn="ctr"/>
+            <a:r>
+              <a:rPr sz="1100" b="1">
+                <a:solidFill>
+                  <a:srgbClr val="FFFFFF"/>
+                </a:solidFill>
+                <a:latin typeface="Calibri"/>
+              </a:rPr>
+              <a:t>EXTENDED KNOWLEDGE</a:t>
+            </a:r>
+          </a:p>
+        </p:txBody>
+      </p:sp>
+      <p:sp>
+        <p:nvSpPr>
+          <p:cNvPr id="3" name="TextBox 2"/>
+          <p:cNvSpPr txBox="1"/>
+          <p:nvPr/>
+        </p:nvSpPr>
+        <p:spPr>
+          <a:xfrm>
+            <a:off x="685800" y="1051560"/>
+            <a:ext cx="10607040" cy="822960"/>
+          </a:xfrm>
+          <a:prstGeom prst="rect">
+            <a:avLst/>
+          </a:prstGeom>
+          <a:noFill/>
+        </p:spPr>
+        <p:txBody>
+          <a:bodyPr wrap="square" anchor="t">
+            <a:spAutoFit/>
+          </a:bodyPr>
+          <a:lstStyle/>
+          <a:p>
+            <a:pPr algn="l"/>
+            <a:r>
+              <a:rPr sz="2700" b="1" i="0">
+                <a:solidFill>
+                  <a:srgbClr val="2B2320"/>
+                </a:solidFill>
+                <a:latin typeface="Cambria"/>
+              </a:rPr>
+              <a:t>Semiotics Basics</a:t>
+            </a:r>
+          </a:p>
+        </p:txBody>
+      </p:sp>
+      <p:sp>
+        <p:nvSpPr>
+          <p:cNvPr id="4" name="Rounded Rectangle 3"/>
+          <p:cNvSpPr/>
+          <p:nvPr/>
+        </p:nvSpPr>
+        <p:spPr>
+          <a:xfrm>
+            <a:off x="685800" y="1874519"/>
+            <a:ext cx="10607040" cy="4526280"/>
+          </a:xfrm>
+          <a:prstGeom prst="roundRect">
+            <a:avLst>
+              <a:gd name="adj" fmla="val 6000"/>
+            </a:avLst>
+          </a:prstGeom>
+          <a:solidFill>
+            <a:srgbClr val="E8F0F0"/>
+          </a:solidFill>
+          <a:ln>
+            <a:noFill/>
+          </a:ln>
+          <a:effectLst/>
+        </p:spPr>
+        <p:style>
+          <a:lnRef idx="1">
+            <a:schemeClr val="accent1"/>
+          </a:lnRef>
+          <a:fillRef idx="3">
+            <a:schemeClr val="accent1"/>
+          </a:fillRef>
+          <a:effectRef idx="2">
+            <a:schemeClr val="accent1"/>
+          </a:effectRef>
+          <a:fontRef idx="minor">
+            <a:schemeClr val="lt1"/>
+          </a:fontRef>
+        </p:style>
+        <p:txBody>
+          <a:bodyPr rtlCol="0" anchor="ctr" lIns="330200" rIns="330200" tIns="254000" bIns="254000" wrap="square"/>
+          <a:lstStyle/>
+          <a:p>
+            <a:pPr algn="ctr" indent="-203200" marL="203200">
+              <a:spcAft>
+                <a:spcPts val="900"/>
+              </a:spcAft>
+              <a:buClr>
+                <a:srgbClr val="1F6F6B"/>
+              </a:buClr>
+              <a:buSzPct val="90000"/>
+              <a:buFont typeface="Arial"/>
+              <a:buChar char="●"/>
+            </a:pPr>
+            <a:r>
+              <a:rPr sz="1500" b="1" i="0">
+                <a:solidFill>
+                  <a:srgbClr val="1A5E5A"/>
+                </a:solidFill>
+                <a:latin typeface="Calibri"/>
+              </a:rPr>
+              <a:t>Icon, index, symbol (Peirce's model)</a:t>
+            </a:r>
+          </a:p>
+          <a:p>
+            <a:pPr indent="-203200" marL="203200">
+              <a:spcAft>
+                <a:spcPts val="900"/>
+              </a:spcAft>
+              <a:buClr>
+                <a:srgbClr val="1F6F6B"/>
+              </a:buClr>
+              <a:buSzPct val="90000"/>
+              <a:buFont typeface="Arial"/>
+              <a:buChar char="–"/>
+            </a:pPr>
+            <a:r>
+              <a:rPr sz="1350" b="0" i="0">
+                <a:solidFill>
+                  <a:srgbClr val="2B2320"/>
+                </a:solidFill>
+                <a:latin typeface="Calibri"/>
+              </a:rPr>
+              <a:t>Icon — resembles what it represents (a photograph, a silhouette of a person)</a:t>
+            </a:r>
+          </a:p>
+          <a:p>
+            <a:pPr indent="-203200" marL="203200">
+              <a:spcAft>
+                <a:spcPts val="900"/>
+              </a:spcAft>
+              <a:buClr>
+                <a:srgbClr val="1F6F6B"/>
+              </a:buClr>
+              <a:buSzPct val="90000"/>
+              <a:buFont typeface="Arial"/>
+              <a:buChar char="–"/>
+            </a:pPr>
+            <a:r>
+              <a:rPr sz="1350" b="0" i="0">
+                <a:solidFill>
+                  <a:srgbClr val="2B2320"/>
+                </a:solidFill>
+                <a:latin typeface="Calibri"/>
+              </a:rPr>
+              <a:t>Index — has a direct/causal link to what it represents (smoke indicates fire)</a:t>
+            </a:r>
+          </a:p>
+          <a:p>
+            <a:pPr indent="-203200" marL="203200">
+              <a:spcAft>
+                <a:spcPts val="900"/>
+              </a:spcAft>
+              <a:buClr>
+                <a:srgbClr val="1F6F6B"/>
+              </a:buClr>
+              <a:buSzPct val="90000"/>
+              <a:buFont typeface="Arial"/>
+              <a:buChar char="–"/>
+            </a:pPr>
+            <a:r>
+              <a:rPr sz="1350" b="0" i="0">
+                <a:solidFill>
+                  <a:srgbClr val="2B2320"/>
+                </a:solidFill>
+                <a:latin typeface="Calibri"/>
+              </a:rPr>
+              <a:t>Symbol — meaning is learned/agreed by convention (a red cross, a national flag)</a:t>
+            </a:r>
+          </a:p>
+          <a:p>
+            <a:pPr indent="-203200" marL="203200">
+              <a:spcAft>
+                <a:spcPts val="900"/>
+              </a:spcAft>
+              <a:buClr>
+                <a:srgbClr val="1F6F6B"/>
+              </a:buClr>
+              <a:buSzPct val="90000"/>
+              <a:buFont typeface="Arial"/>
+              <a:buChar char="●"/>
+            </a:pPr>
+            <a:r>
+              <a:rPr sz="1500" b="1" i="0">
+                <a:solidFill>
+                  <a:srgbClr val="1A5E5A"/>
+                </a:solidFill>
+                <a:latin typeface="Calibri"/>
+              </a:rPr>
+              <a:t>Denotation vs connotation</a:t>
+            </a:r>
+          </a:p>
+          <a:p>
+            <a:pPr indent="-203200" marL="203200">
+              <a:spcAft>
+                <a:spcPts val="900"/>
+              </a:spcAft>
+              <a:buClr>
+                <a:srgbClr val="1F6F6B"/>
+              </a:buClr>
+              <a:buSzPct val="90000"/>
+              <a:buFont typeface="Arial"/>
+              <a:buChar char="–"/>
+            </a:pPr>
+            <a:r>
+              <a:rPr sz="1350" b="0" i="0">
+                <a:solidFill>
+                  <a:srgbClr val="2B2320"/>
+                </a:solidFill>
+                <a:latin typeface="Calibri"/>
+              </a:rPr>
+              <a:t>Denotation is the literal, surface meaning of an image or mark. Connotation is the cultural or emotional association layered on top. A logo's shape (denotation) might connote luxury, playfulness or trustworthiness depending on colour, form and context.</a:t>
+            </a:r>
+          </a:p>
+        </p:txBody>
+      </p:sp>
+      <p:sp>
+        <p:nvSpPr>
+          <p:cNvPr id="5" name="Oval 4"/>
+          <p:cNvSpPr/>
+          <p:nvPr/>
+        </p:nvSpPr>
+        <p:spPr>
+          <a:xfrm>
+            <a:off x="10881360" y="5943600"/>
+            <a:ext cx="1005840" cy="1005840"/>
+          </a:xfrm>
+          <a:prstGeom prst="ellipse">
+            <a:avLst/>
+          </a:prstGeom>
+          <a:solidFill>
+            <a:srgbClr val="F4B8C3"/>
+          </a:solidFill>
+          <a:ln>
+            <a:noFill/>
+          </a:ln>
+          <a:effectLst/>
+        </p:spPr>
+        <p:style>
+          <a:lnRef idx="1">
+            <a:schemeClr val="accent1"/>
+          </a:lnRef>
+          <a:fillRef idx="3">
+            <a:schemeClr val="accent1"/>
+          </a:fillRef>
+          <a:effectRef idx="2">
+            <a:schemeClr val="accent1"/>
+          </a:effectRef>
+          <a:fontRef idx="minor">
+            <a:schemeClr val="lt1"/>
+          </a:fontRef>
+        </p:style>
+        <p:txBody>
+          <a:bodyPr rtlCol="0" anchor="ctr"/>
+          <a:lstStyle/>
+          <a:p>
+            <a:pPr algn="ctr"/>
+          </a:p>
+        </p:txBody>
+      </p:sp>
+    </p:spTree>
+  </p:cSld>
+  <p:clrMapOvr>
+    <a:masterClrMapping/>
+  </p:clrMapOvr>
+</p:sld>
+</file>
+
+<file path=ppt/slides/slide65.xml><?xml version="1.0" encoding="utf-8"?>
+<p:sld xmlns:a="http://schemas.openxmlformats.org/drawingml/2006/main" xmlns:p="http://schemas.openxmlformats.org/presentationml/2006/main" xmlns:r="http://schemas.openxmlformats.org/officeDocument/2006/relationships">
+  <p:cSld>
+    <p:bg>
+      <p:bgPr>
+        <a:solidFill>
+          <a:srgbClr val="FCF8F1"/>
+        </a:solidFill>
+        <a:effectLst/>
+      </p:bgPr>
+    </p:bg>
+    <p:spTree>
+      <p:nvGrpSpPr>
+        <p:cNvPr id="1" name=""/>
+        <p:cNvGrpSpPr/>
+        <p:nvPr/>
+      </p:nvGrpSpPr>
+      <p:grpSpPr/>
+      <p:sp>
+        <p:nvSpPr>
+          <p:cNvPr id="2" name="Rounded Rectangle 1"/>
+          <p:cNvSpPr/>
+          <p:nvPr/>
+        </p:nvSpPr>
+        <p:spPr>
+          <a:xfrm>
+            <a:off x="685800" y="502920"/>
+            <a:ext cx="3291840" cy="457200"/>
+          </a:xfrm>
+          <a:prstGeom prst="roundRect">
+            <a:avLst>
+              <a:gd name="adj" fmla="val 50000"/>
+            </a:avLst>
+          </a:prstGeom>
+          <a:solidFill>
+            <a:srgbClr val="1F6F6B"/>
+          </a:solidFill>
+          <a:ln>
+            <a:noFill/>
+          </a:ln>
+          <a:effectLst/>
+        </p:spPr>
+        <p:style>
+          <a:lnRef idx="1">
+            <a:schemeClr val="accent1"/>
+          </a:lnRef>
+          <a:fillRef idx="3">
+            <a:schemeClr val="accent1"/>
+          </a:fillRef>
+          <a:effectRef idx="2">
+            <a:schemeClr val="accent1"/>
+          </a:effectRef>
+          <a:fontRef idx="minor">
+            <a:schemeClr val="lt1"/>
+          </a:fontRef>
+        </p:style>
+        <p:txBody>
+          <a:bodyPr rtlCol="0" anchor="ctr" wrap="none" lIns="50800" rIns="50800"/>
+          <a:lstStyle/>
+          <a:p>
+            <a:pPr algn="ctr"/>
+            <a:r>
+              <a:rPr sz="1100" b="1">
+                <a:solidFill>
+                  <a:srgbClr val="FFFFFF"/>
+                </a:solidFill>
+                <a:latin typeface="Calibri"/>
+              </a:rPr>
+              <a:t>EXTENDED KNOWLEDGE</a:t>
+            </a:r>
+          </a:p>
+        </p:txBody>
+      </p:sp>
+      <p:sp>
+        <p:nvSpPr>
+          <p:cNvPr id="3" name="TextBox 2"/>
+          <p:cNvSpPr txBox="1"/>
+          <p:nvPr/>
+        </p:nvSpPr>
+        <p:spPr>
+          <a:xfrm>
+            <a:off x="685800" y="1051560"/>
+            <a:ext cx="10607040" cy="822960"/>
+          </a:xfrm>
+          <a:prstGeom prst="rect">
+            <a:avLst/>
+          </a:prstGeom>
+          <a:noFill/>
+        </p:spPr>
+        <p:txBody>
+          <a:bodyPr wrap="square" anchor="t">
+            <a:spAutoFit/>
+          </a:bodyPr>
+          <a:lstStyle/>
+          <a:p>
+            <a:pPr algn="l"/>
+            <a:r>
+              <a:rPr sz="2700" b="1" i="0">
+                <a:solidFill>
+                  <a:srgbClr val="2B2320"/>
+                </a:solidFill>
+                <a:latin typeface="Cambria"/>
+              </a:rPr>
+              <a:t>Design Thinking Frameworks</a:t>
+            </a:r>
+          </a:p>
+        </p:txBody>
+      </p:sp>
+      <p:sp>
+        <p:nvSpPr>
+          <p:cNvPr id="4" name="Rounded Rectangle 3"/>
+          <p:cNvSpPr/>
+          <p:nvPr/>
+        </p:nvSpPr>
+        <p:spPr>
+          <a:xfrm>
+            <a:off x="685800" y="1874519"/>
+            <a:ext cx="10607040" cy="4526280"/>
+          </a:xfrm>
+          <a:prstGeom prst="roundRect">
+            <a:avLst>
+              <a:gd name="adj" fmla="val 6000"/>
+            </a:avLst>
+          </a:prstGeom>
+          <a:solidFill>
+            <a:srgbClr val="E8F0F0"/>
+          </a:solidFill>
+          <a:ln>
+            <a:noFill/>
+          </a:ln>
+          <a:effectLst/>
+        </p:spPr>
+        <p:style>
+          <a:lnRef idx="1">
+            <a:schemeClr val="accent1"/>
+          </a:lnRef>
+          <a:fillRef idx="3">
+            <a:schemeClr val="accent1"/>
+          </a:fillRef>
+          <a:effectRef idx="2">
+            <a:schemeClr val="accent1"/>
+          </a:effectRef>
+          <a:fontRef idx="minor">
+            <a:schemeClr val="lt1"/>
+          </a:fontRef>
+        </p:style>
+        <p:txBody>
+          <a:bodyPr rtlCol="0" anchor="ctr" lIns="330200" rIns="330200" tIns="254000" bIns="254000" wrap="square"/>
+          <a:lstStyle/>
+          <a:p>
+            <a:pPr algn="ctr" indent="-203200" marL="203200">
+              <a:spcAft>
+                <a:spcPts val="900"/>
+              </a:spcAft>
+              <a:buClr>
+                <a:srgbClr val="1F6F6B"/>
+              </a:buClr>
+              <a:buSzPct val="90000"/>
+              <a:buFont typeface="Arial"/>
+              <a:buChar char="●"/>
+            </a:pPr>
+            <a:r>
+              <a:rPr sz="1500" b="1" i="0">
+                <a:solidFill>
+                  <a:srgbClr val="1A5E5A"/>
+                </a:solidFill>
+                <a:latin typeface="Calibri"/>
+              </a:rPr>
+              <a:t>The Double Diamond</a:t>
+            </a:r>
+          </a:p>
+          <a:p>
+            <a:pPr indent="-203200" marL="203200">
+              <a:spcAft>
+                <a:spcPts val="900"/>
+              </a:spcAft>
+              <a:buClr>
+                <a:srgbClr val="1F6F6B"/>
+              </a:buClr>
+              <a:buSzPct val="90000"/>
+              <a:buFont typeface="Arial"/>
+              <a:buChar char="–"/>
+            </a:pPr>
+            <a:r>
+              <a:rPr sz="1350" b="0" i="0">
+                <a:solidFill>
+                  <a:srgbClr val="2B2320"/>
+                </a:solidFill>
+                <a:latin typeface="Calibri"/>
+              </a:rPr>
+              <a:t>A widely used design process model with four phases: Discover (explore the problem), Define (narrow to a clear brief), Develop (generate and test solutions), Deliver (finalise and launch). Compares directly to the VCAA design process stages studied this unit.</a:t>
+            </a:r>
+          </a:p>
+          <a:p>
+            <a:pPr indent="-203200" marL="203200">
+              <a:spcAft>
+                <a:spcPts val="900"/>
+              </a:spcAft>
+              <a:buClr>
+                <a:srgbClr val="1F6F6B"/>
+              </a:buClr>
+              <a:buSzPct val="90000"/>
+              <a:buFont typeface="Arial"/>
+              <a:buChar char="●"/>
+            </a:pPr>
+            <a:r>
+              <a:rPr sz="1500" b="1" i="0">
+                <a:solidFill>
+                  <a:srgbClr val="1A5E5A"/>
+                </a:solidFill>
+                <a:latin typeface="Calibri"/>
+              </a:rPr>
+              <a:t>IDEO's Design Thinking model</a:t>
+            </a:r>
+          </a:p>
+          <a:p>
+            <a:pPr indent="-203200" marL="203200">
+              <a:spcAft>
+                <a:spcPts val="900"/>
+              </a:spcAft>
+              <a:buClr>
+                <a:srgbClr val="1F6F6B"/>
+              </a:buClr>
+              <a:buSzPct val="90000"/>
+              <a:buFont typeface="Arial"/>
+              <a:buChar char="–"/>
+            </a:pPr>
+            <a:r>
+              <a:rPr sz="1350" b="0" i="0">
+                <a:solidFill>
+                  <a:srgbClr val="2B2320"/>
+                </a:solidFill>
+                <a:latin typeface="Calibri"/>
+              </a:rPr>
+              <a:t>Empathise, Define, Ideate, Prototype, Test — an iterative, human-centred process widely used in industry, especially for digital/interaction design.</a:t>
+            </a:r>
+          </a:p>
+          <a:p>
+            <a:pPr indent="-203200" marL="203200">
+              <a:spcAft>
+                <a:spcPts val="900"/>
+              </a:spcAft>
+              <a:buClr>
+                <a:srgbClr val="1F6F6B"/>
+              </a:buClr>
+              <a:buSzPct val="90000"/>
+              <a:buFont typeface="Arial"/>
+              <a:buChar char="●"/>
+            </a:pPr>
+            <a:r>
+              <a:rPr sz="1500" b="1" i="0">
+                <a:solidFill>
+                  <a:srgbClr val="1A5E5A"/>
+                </a:solidFill>
+                <a:latin typeface="Calibri"/>
+              </a:rPr>
+              <a:t>The Design Sprint</a:t>
+            </a:r>
+          </a:p>
+          <a:p>
+            <a:pPr indent="-203200" marL="203200">
+              <a:spcAft>
+                <a:spcPts val="900"/>
+              </a:spcAft>
+              <a:buClr>
+                <a:srgbClr val="1F6F6B"/>
+              </a:buClr>
+              <a:buSzPct val="90000"/>
+              <a:buFont typeface="Arial"/>
+              <a:buChar char="–"/>
+            </a:pPr>
+            <a:r>
+              <a:rPr sz="1350" b="0" i="0">
+                <a:solidFill>
+                  <a:srgbClr val="2B2320"/>
+                </a:solidFill>
+                <a:latin typeface="Calibri"/>
+              </a:rPr>
+              <a:t>A 5-day process (popularised by Google Ventures) for answering critical design questions through prototyping and user testing before committing significant resources to a project.</a:t>
+            </a:r>
+          </a:p>
+        </p:txBody>
+      </p:sp>
+      <p:sp>
+        <p:nvSpPr>
+          <p:cNvPr id="5" name="Oval 4"/>
+          <p:cNvSpPr/>
+          <p:nvPr/>
+        </p:nvSpPr>
+        <p:spPr>
+          <a:xfrm>
+            <a:off x="10881360" y="5943600"/>
+            <a:ext cx="1005840" cy="1005840"/>
+          </a:xfrm>
+          <a:prstGeom prst="ellipse">
+            <a:avLst/>
+          </a:prstGeom>
+          <a:solidFill>
+            <a:srgbClr val="F4B8C3"/>
+          </a:solidFill>
+          <a:ln>
+            <a:noFill/>
+          </a:ln>
+          <a:effectLst/>
+        </p:spPr>
+        <p:style>
+          <a:lnRef idx="1">
+            <a:schemeClr val="accent1"/>
+          </a:lnRef>
+          <a:fillRef idx="3">
+            <a:schemeClr val="accent1"/>
+          </a:fillRef>
+          <a:effectRef idx="2">
+            <a:schemeClr val="accent1"/>
+          </a:effectRef>
+          <a:fontRef idx="minor">
+            <a:schemeClr val="lt1"/>
+          </a:fontRef>
+        </p:style>
+        <p:txBody>
+          <a:bodyPr rtlCol="0" anchor="ctr"/>
+          <a:lstStyle/>
+          <a:p>
+            <a:pPr algn="ctr"/>
+          </a:p>
+        </p:txBody>
+      </p:sp>
+    </p:spTree>
+  </p:cSld>
+  <p:clrMapOvr>
+    <a:masterClrMapping/>
+  </p:clrMapOvr>
+</p:sld>
+</file>
+
+<file path=ppt/slides/slide66.xml><?xml version="1.0" encoding="utf-8"?>
+<p:sld xmlns:a="http://schemas.openxmlformats.org/drawingml/2006/main" xmlns:p="http://schemas.openxmlformats.org/presentationml/2006/main" xmlns:r="http://schemas.openxmlformats.org/officeDocument/2006/relationships">
+  <p:cSld>
+    <p:bg>
+      <p:bgPr>
+        <a:solidFill>
+          <a:srgbClr val="FCF8F1"/>
+        </a:solidFill>
+        <a:effectLst/>
+      </p:bgPr>
+    </p:bg>
+    <p:spTree>
+      <p:nvGrpSpPr>
+        <p:cNvPr id="1" name=""/>
+        <p:cNvGrpSpPr/>
+        <p:nvPr/>
+      </p:nvGrpSpPr>
+      <p:grpSpPr/>
+      <p:sp>
+        <p:nvSpPr>
+          <p:cNvPr id="2" name="Rounded Rectangle 1"/>
+          <p:cNvSpPr/>
+          <p:nvPr/>
+        </p:nvSpPr>
+        <p:spPr>
+          <a:xfrm>
+            <a:off x="685800" y="502920"/>
+            <a:ext cx="3291840" cy="457200"/>
+          </a:xfrm>
+          <a:prstGeom prst="roundRect">
+            <a:avLst>
+              <a:gd name="adj" fmla="val 50000"/>
+            </a:avLst>
+          </a:prstGeom>
+          <a:solidFill>
+            <a:srgbClr val="1F6F6B"/>
+          </a:solidFill>
+          <a:ln>
+            <a:noFill/>
+          </a:ln>
+          <a:effectLst/>
+        </p:spPr>
+        <p:style>
+          <a:lnRef idx="1">
+            <a:schemeClr val="accent1"/>
+          </a:lnRef>
+          <a:fillRef idx="3">
+            <a:schemeClr val="accent1"/>
+          </a:fillRef>
+          <a:effectRef idx="2">
+            <a:schemeClr val="accent1"/>
+          </a:effectRef>
+          <a:fontRef idx="minor">
+            <a:schemeClr val="lt1"/>
+          </a:fontRef>
+        </p:style>
+        <p:txBody>
+          <a:bodyPr rtlCol="0" anchor="ctr" wrap="none" lIns="50800" rIns="50800"/>
+          <a:lstStyle/>
+          <a:p>
+            <a:pPr algn="ctr"/>
+            <a:r>
+              <a:rPr sz="1100" b="1">
+                <a:solidFill>
+                  <a:srgbClr val="FFFFFF"/>
+                </a:solidFill>
+                <a:latin typeface="Calibri"/>
+              </a:rPr>
+              <a:t>EXTENDED KNOWLEDGE</a:t>
+            </a:r>
+          </a:p>
+        </p:txBody>
+      </p:sp>
+      <p:sp>
+        <p:nvSpPr>
+          <p:cNvPr id="3" name="TextBox 2"/>
+          <p:cNvSpPr txBox="1"/>
+          <p:nvPr/>
+        </p:nvSpPr>
+        <p:spPr>
+          <a:xfrm>
+            <a:off x="685800" y="1051560"/>
+            <a:ext cx="10607040" cy="822960"/>
+          </a:xfrm>
+          <a:prstGeom prst="rect">
+            <a:avLst/>
+          </a:prstGeom>
+          <a:noFill/>
+        </p:spPr>
+        <p:txBody>
+          <a:bodyPr wrap="square" anchor="t">
+            <a:spAutoFit/>
+          </a:bodyPr>
+          <a:lstStyle/>
+          <a:p>
+            <a:pPr algn="l"/>
+            <a:r>
+              <a:rPr sz="2700" b="1" i="0">
+                <a:solidFill>
+                  <a:srgbClr val="2B2320"/>
+                </a:solidFill>
+                <a:latin typeface="Cambria"/>
+              </a:rPr>
+              <a:t>Industry-Standard Digital Tools</a:t>
+            </a:r>
+          </a:p>
+        </p:txBody>
+      </p:sp>
+      <p:sp>
+        <p:nvSpPr>
+          <p:cNvPr id="4" name="Rounded Rectangle 3"/>
+          <p:cNvSpPr/>
+          <p:nvPr/>
+        </p:nvSpPr>
+        <p:spPr>
+          <a:xfrm>
+            <a:off x="685800" y="1874519"/>
+            <a:ext cx="10607040" cy="4526280"/>
+          </a:xfrm>
+          <a:prstGeom prst="roundRect">
+            <a:avLst>
+              <a:gd name="adj" fmla="val 6000"/>
+            </a:avLst>
+          </a:prstGeom>
+          <a:solidFill>
+            <a:srgbClr val="E8F0F0"/>
+          </a:solidFill>
+          <a:ln>
+            <a:noFill/>
+          </a:ln>
+          <a:effectLst/>
+        </p:spPr>
+        <p:style>
+          <a:lnRef idx="1">
+            <a:schemeClr val="accent1"/>
+          </a:lnRef>
+          <a:fillRef idx="3">
+            <a:schemeClr val="accent1"/>
+          </a:fillRef>
+          <a:effectRef idx="2">
+            <a:schemeClr val="accent1"/>
+          </a:effectRef>
+          <a:fontRef idx="minor">
+            <a:schemeClr val="lt1"/>
+          </a:fontRef>
+        </p:style>
+        <p:txBody>
+          <a:bodyPr rtlCol="0" anchor="ctr" lIns="330200" rIns="330200" tIns="254000" bIns="254000" wrap="square"/>
+          <a:lstStyle/>
+          <a:p>
+            <a:pPr algn="ctr" indent="-203200" marL="203200">
+              <a:spcAft>
+                <a:spcPts val="900"/>
+              </a:spcAft>
+              <a:buClr>
+                <a:srgbClr val="1F6F6B"/>
+              </a:buClr>
+              <a:buSzPct val="90000"/>
+              <a:buFont typeface="Arial"/>
+              <a:buChar char="●"/>
+            </a:pPr>
+            <a:r>
+              <a:rPr sz="1500" b="1" i="0">
+                <a:solidFill>
+                  <a:srgbClr val="1A5E5A"/>
+                </a:solidFill>
+                <a:latin typeface="Calibri"/>
+              </a:rPr>
+              <a:t>Common software by purpose</a:t>
+            </a:r>
+          </a:p>
+          <a:p>
+            <a:pPr indent="-203200" marL="203200">
+              <a:spcAft>
+                <a:spcPts val="900"/>
+              </a:spcAft>
+              <a:buClr>
+                <a:srgbClr val="1F6F6B"/>
+              </a:buClr>
+              <a:buSzPct val="90000"/>
+              <a:buFont typeface="Arial"/>
+              <a:buChar char="–"/>
+            </a:pPr>
+            <a:r>
+              <a:rPr sz="1350" b="0" i="0">
+                <a:solidFill>
+                  <a:srgbClr val="2B2320"/>
+                </a:solidFill>
+                <a:latin typeface="Calibri"/>
+              </a:rPr>
+              <a:t>Adobe Illustrator — vector illustration, logos, layout elements</a:t>
+            </a:r>
+          </a:p>
+          <a:p>
+            <a:pPr indent="-203200" marL="203200">
+              <a:spcAft>
+                <a:spcPts val="900"/>
+              </a:spcAft>
+              <a:buClr>
+                <a:srgbClr val="1F6F6B"/>
+              </a:buClr>
+              <a:buSzPct val="90000"/>
+              <a:buFont typeface="Arial"/>
+              <a:buChar char="–"/>
+            </a:pPr>
+            <a:r>
+              <a:rPr sz="1350" b="0" i="0">
+                <a:solidFill>
+                  <a:srgbClr val="2B2320"/>
+                </a:solidFill>
+                <a:latin typeface="Calibri"/>
+              </a:rPr>
+              <a:t>Adobe Photoshop — raster image editing, photo manipulation, rendering</a:t>
+            </a:r>
+          </a:p>
+          <a:p>
+            <a:pPr indent="-203200" marL="203200">
+              <a:spcAft>
+                <a:spcPts val="900"/>
+              </a:spcAft>
+              <a:buClr>
+                <a:srgbClr val="1F6F6B"/>
+              </a:buClr>
+              <a:buSzPct val="90000"/>
+              <a:buFont typeface="Arial"/>
+              <a:buChar char="–"/>
+            </a:pPr>
+            <a:r>
+              <a:rPr sz="1350" b="0" i="0">
+                <a:solidFill>
+                  <a:srgbClr val="2B2320"/>
+                </a:solidFill>
+                <a:latin typeface="Calibri"/>
+              </a:rPr>
+              <a:t>Adobe InDesign — multi-page layout (magazines, brochures, books)</a:t>
+            </a:r>
+          </a:p>
+          <a:p>
+            <a:pPr indent="-203200" marL="203200">
+              <a:spcAft>
+                <a:spcPts val="900"/>
+              </a:spcAft>
+              <a:buClr>
+                <a:srgbClr val="1F6F6B"/>
+              </a:buClr>
+              <a:buSzPct val="90000"/>
+              <a:buFont typeface="Arial"/>
+              <a:buChar char="–"/>
+            </a:pPr>
+            <a:r>
+              <a:rPr sz="1350" b="0" i="0">
+                <a:solidFill>
+                  <a:srgbClr val="2B2320"/>
+                </a:solidFill>
+                <a:latin typeface="Calibri"/>
+              </a:rPr>
+              <a:t>Figma — UI/UX design and prototyping, collaborative interface design</a:t>
+            </a:r>
+          </a:p>
+          <a:p>
+            <a:pPr indent="-203200" marL="203200">
+              <a:spcAft>
+                <a:spcPts val="900"/>
+              </a:spcAft>
+              <a:buClr>
+                <a:srgbClr val="1F6F6B"/>
+              </a:buClr>
+              <a:buSzPct val="90000"/>
+              <a:buFont typeface="Arial"/>
+              <a:buChar char="–"/>
+            </a:pPr>
+            <a:r>
+              <a:rPr sz="1350" b="0" i="0">
+                <a:solidFill>
+                  <a:srgbClr val="2B2320"/>
+                </a:solidFill>
+                <a:latin typeface="Calibri"/>
+              </a:rPr>
+              <a:t>Procreate — digital sketching and illustration on tablet devices</a:t>
+            </a:r>
+          </a:p>
+        </p:txBody>
+      </p:sp>
+      <p:sp>
+        <p:nvSpPr>
+          <p:cNvPr id="5" name="Oval 4"/>
+          <p:cNvSpPr/>
+          <p:nvPr/>
+        </p:nvSpPr>
+        <p:spPr>
+          <a:xfrm>
+            <a:off x="10881360" y="5943600"/>
+            <a:ext cx="1005840" cy="1005840"/>
+          </a:xfrm>
+          <a:prstGeom prst="ellipse">
+            <a:avLst/>
+          </a:prstGeom>
+          <a:solidFill>
+            <a:srgbClr val="F4B8C3"/>
+          </a:solidFill>
+          <a:ln>
+            <a:noFill/>
+          </a:ln>
+          <a:effectLst/>
+        </p:spPr>
+        <p:style>
+          <a:lnRef idx="1">
+            <a:schemeClr val="accent1"/>
+          </a:lnRef>
+          <a:fillRef idx="3">
+            <a:schemeClr val="accent1"/>
+          </a:fillRef>
+          <a:effectRef idx="2">
+            <a:schemeClr val="accent1"/>
+          </a:effectRef>
+          <a:fontRef idx="minor">
+            <a:schemeClr val="lt1"/>
+          </a:fontRef>
+        </p:style>
+        <p:txBody>
+          <a:bodyPr rtlCol="0" anchor="ctr"/>
+          <a:lstStyle/>
+          <a:p>
+            <a:pPr algn="ctr"/>
+          </a:p>
+        </p:txBody>
+      </p:sp>
+    </p:spTree>
+  </p:cSld>
+  <p:clrMapOvr>
+    <a:masterClrMapping/>
+  </p:clrMapOvr>
+</p:sld>
+</file>
+
+<file path=ppt/slides/slide67.xml><?xml version="1.0" encoding="utf-8"?>
+<p:sld xmlns:a="http://schemas.openxmlformats.org/drawingml/2006/main" xmlns:p="http://schemas.openxmlformats.org/presentationml/2006/main" xmlns:r="http://schemas.openxmlformats.org/officeDocument/2006/relationships">
+  <p:cSld>
+    <p:bg>
+      <p:bgPr>
+        <a:solidFill>
+          <a:srgbClr val="E8A23A"/>
+        </a:solidFill>
+        <a:effectLst/>
+      </p:bgPr>
+    </p:bg>
+    <p:spTree>
+      <p:nvGrpSpPr>
+        <p:cNvPr id="1" name=""/>
+        <p:cNvGrpSpPr/>
+        <p:nvPr/>
+      </p:nvGrpSpPr>
+      <p:grpSpPr/>
+      <p:sp>
+        <p:nvSpPr>
+          <p:cNvPr id="2" name="Oval 1"/>
+          <p:cNvSpPr/>
+          <p:nvPr/>
+        </p:nvSpPr>
+        <p:spPr>
+          <a:xfrm>
+            <a:off x="9692640" y="-914400"/>
+            <a:ext cx="2926080" cy="2926080"/>
+          </a:xfrm>
+          <a:prstGeom prst="ellipse">
+            <a:avLst/>
+          </a:prstGeom>
+          <a:solidFill>
+            <a:srgbClr val="CC8E33"/>
+          </a:solidFill>
+          <a:ln>
+            <a:noFill/>
+          </a:ln>
+          <a:effectLst/>
+        </p:spPr>
+        <p:style>
+          <a:lnRef idx="1">
+            <a:schemeClr val="accent1"/>
+          </a:lnRef>
+          <a:fillRef idx="3">
+            <a:schemeClr val="accent1"/>
+          </a:fillRef>
+          <a:effectRef idx="2">
+            <a:schemeClr val="accent1"/>
+          </a:effectRef>
+          <a:fontRef idx="minor">
+            <a:schemeClr val="lt1"/>
+          </a:fontRef>
+        </p:style>
+        <p:txBody>
+          <a:bodyPr rtlCol="0" anchor="ctr"/>
+          <a:lstStyle/>
+          <a:p>
+            <a:pPr algn="ctr"/>
+          </a:p>
+        </p:txBody>
+      </p:sp>
+      <p:sp>
+        <p:nvSpPr>
+          <p:cNvPr id="3" name="Oval 2"/>
+          <p:cNvSpPr/>
+          <p:nvPr/>
+        </p:nvSpPr>
+        <p:spPr>
+          <a:xfrm>
+            <a:off x="-914400" y="4937760"/>
+            <a:ext cx="2377440" cy="2377440"/>
+          </a:xfrm>
+          <a:prstGeom prst="ellipse">
+            <a:avLst/>
+          </a:prstGeom>
+          <a:solidFill>
+            <a:srgbClr val="CC8E33"/>
+          </a:solidFill>
+          <a:ln>
+            <a:noFill/>
+          </a:ln>
+          <a:effectLst/>
+        </p:spPr>
+        <p:style>
+          <a:lnRef idx="1">
+            <a:schemeClr val="accent1"/>
+          </a:lnRef>
+          <a:fillRef idx="3">
+            <a:schemeClr val="accent1"/>
+          </a:fillRef>
+          <a:effectRef idx="2">
+            <a:schemeClr val="accent1"/>
+          </a:effectRef>
+          <a:fontRef idx="minor">
+            <a:schemeClr val="lt1"/>
+          </a:fontRef>
+        </p:style>
+        <p:txBody>
+          <a:bodyPr rtlCol="0" anchor="ctr"/>
+          <a:lstStyle/>
+          <a:p>
+            <a:pPr algn="ctr"/>
+          </a:p>
+        </p:txBody>
+      </p:sp>
+      <p:sp>
+        <p:nvSpPr>
+          <p:cNvPr id="4" name="Rounded Rectangle 3"/>
+          <p:cNvSpPr/>
+          <p:nvPr/>
+        </p:nvSpPr>
+        <p:spPr>
+          <a:xfrm>
+            <a:off x="822960" y="1051560"/>
+            <a:ext cx="1188720" cy="502920"/>
+          </a:xfrm>
+          <a:prstGeom prst="roundRect">
+            <a:avLst>
+              <a:gd name="adj" fmla="val 50000"/>
+            </a:avLst>
+          </a:prstGeom>
+          <a:solidFill>
+            <a:srgbClr val="FFFFFF"/>
+          </a:solidFill>
+          <a:ln>
+            <a:noFill/>
+          </a:ln>
+          <a:effectLst/>
+        </p:spPr>
+        <p:style>
+          <a:lnRef idx="1">
+            <a:schemeClr val="accent1"/>
+          </a:lnRef>
+          <a:fillRef idx="3">
+            <a:schemeClr val="accent1"/>
+          </a:fillRef>
+          <a:effectRef idx="2">
+            <a:schemeClr val="accent1"/>
+          </a:effectRef>
+          <a:fontRef idx="minor">
+            <a:schemeClr val="lt1"/>
+          </a:fontRef>
+        </p:style>
+        <p:txBody>
+          <a:bodyPr rtlCol="0" anchor="ctr" wrap="none" lIns="50800" rIns="50800"/>
+          <a:lstStyle/>
+          <a:p>
+            <a:pPr algn="ctr"/>
+            <a:r>
+              <a:rPr sz="1400" b="1">
+                <a:solidFill>
+                  <a:srgbClr val="B9812E"/>
+                </a:solidFill>
+                <a:latin typeface="Calibri"/>
+              </a:rPr>
+              <a:t>07</a:t>
+            </a:r>
+          </a:p>
+        </p:txBody>
+      </p:sp>
+      <p:sp>
+        <p:nvSpPr>
+          <p:cNvPr id="5" name="Rounded Rectangle 4"/>
+          <p:cNvSpPr/>
+          <p:nvPr/>
+        </p:nvSpPr>
+        <p:spPr>
+          <a:xfrm>
+            <a:off x="822960" y="2011680"/>
+            <a:ext cx="10515600" cy="2834640"/>
+          </a:xfrm>
+          <a:prstGeom prst="roundRect">
+            <a:avLst>
+              <a:gd name="adj" fmla="val 18000"/>
+            </a:avLst>
+          </a:prstGeom>
+          <a:solidFill>
+            <a:srgbClr val="FFFFFF"/>
+          </a:solidFill>
+          <a:ln>
+            <a:noFill/>
+          </a:ln>
+          <a:effectLst/>
+        </p:spPr>
+        <p:style>
+          <a:lnRef idx="1">
+            <a:schemeClr val="accent1"/>
+          </a:lnRef>
+          <a:fillRef idx="3">
+            <a:schemeClr val="accent1"/>
+          </a:fillRef>
+          <a:effectRef idx="2">
+            <a:schemeClr val="accent1"/>
+          </a:effectRef>
+          <a:fontRef idx="minor">
+            <a:schemeClr val="lt1"/>
+          </a:fontRef>
+        </p:style>
+        <p:txBody>
+          <a:bodyPr rtlCol="0" anchor="ctr"/>
+          <a:lstStyle/>
+          <a:p>
+            <a:pPr algn="ctr"/>
+          </a:p>
+        </p:txBody>
+      </p:sp>
+      <p:sp>
+        <p:nvSpPr>
+          <p:cNvPr id="6" name="TextBox 5"/>
+          <p:cNvSpPr txBox="1"/>
+          <p:nvPr/>
+        </p:nvSpPr>
+        <p:spPr>
+          <a:xfrm>
+            <a:off x="1280160" y="2697480"/>
+            <a:ext cx="9601200" cy="1097280"/>
+          </a:xfrm>
+          <a:prstGeom prst="rect">
+            <a:avLst/>
+          </a:prstGeom>
+          <a:noFill/>
+        </p:spPr>
+        <p:txBody>
+          <a:bodyPr wrap="square" anchor="t">
+            <a:spAutoFit/>
+          </a:bodyPr>
+          <a:lstStyle/>
+          <a:p>
+            <a:pPr algn="l"/>
+            <a:r>
+              <a:rPr sz="3400" b="1" i="0">
+                <a:solidFill>
+                  <a:srgbClr val="C58931"/>
+                </a:solidFill>
+                <a:latin typeface="Cambria"/>
+              </a:rPr>
+              <a:t>SAC Briefing</a:t>
+            </a:r>
+          </a:p>
+        </p:txBody>
+      </p:sp>
+      <p:sp>
+        <p:nvSpPr>
+          <p:cNvPr id="7" name="TextBox 6"/>
+          <p:cNvSpPr txBox="1"/>
+          <p:nvPr/>
+        </p:nvSpPr>
+        <p:spPr>
+          <a:xfrm>
+            <a:off x="1280160" y="3657600"/>
+            <a:ext cx="9601200" cy="548640"/>
+          </a:xfrm>
+          <a:prstGeom prst="rect">
+            <a:avLst/>
+          </a:prstGeom>
+          <a:noFill/>
+        </p:spPr>
+        <p:txBody>
+          <a:bodyPr wrap="square" anchor="t">
+            <a:spAutoFit/>
+          </a:bodyPr>
+          <a:lstStyle/>
+          <a:p>
+            <a:pPr algn="l"/>
+            <a:r>
+              <a:rPr sz="1500" b="0" i="0">
+                <a:solidFill>
+                  <a:srgbClr val="6B6B6B"/>
+                </a:solidFill>
+                <a:latin typeface="Calibri"/>
+              </a:rPr>
+              <a:t>Draft — confirm against your school’s SAC schedule</a:t>
+            </a:r>
+          </a:p>
+        </p:txBody>
+      </p:sp>
+    </p:spTree>
+  </p:cSld>
+  <p:clrMapOvr>
+    <a:masterClrMapping/>
+  </p:clrMapOvr>
+</p:sld>
+</file>
+
+<file path=ppt/slides/slide68.xml><?xml version="1.0" encoding="utf-8"?>
+<p:sld xmlns:a="http://schemas.openxmlformats.org/drawingml/2006/main" xmlns:p="http://schemas.openxmlformats.org/presentationml/2006/main" xmlns:r="http://schemas.openxmlformats.org/officeDocument/2006/relationships">
+  <p:cSld>
+    <p:bg>
+      <p:bgPr>
+        <a:solidFill>
+          <a:srgbClr val="FCF8F1"/>
+        </a:solidFill>
+        <a:effectLst/>
+      </p:bgPr>
+    </p:bg>
+    <p:spTree>
+      <p:nvGrpSpPr>
+        <p:cNvPr id="1" name=""/>
+        <p:cNvGrpSpPr/>
+        <p:nvPr/>
+      </p:nvGrpSpPr>
+      <p:grpSpPr/>
+      <p:sp>
+        <p:nvSpPr>
+          <p:cNvPr id="2" name="Rounded Rectangle 1"/>
+          <p:cNvSpPr/>
+          <p:nvPr/>
+        </p:nvSpPr>
+        <p:spPr>
+          <a:xfrm>
+            <a:off x="685800" y="502920"/>
+            <a:ext cx="3291840" cy="457200"/>
+          </a:xfrm>
+          <a:prstGeom prst="roundRect">
+            <a:avLst>
+              <a:gd name="adj" fmla="val 50000"/>
+            </a:avLst>
+          </a:prstGeom>
+          <a:solidFill>
+            <a:srgbClr val="1F6F6B"/>
+          </a:solidFill>
+          <a:ln>
+            <a:noFill/>
+          </a:ln>
+          <a:effectLst/>
+        </p:spPr>
+        <p:style>
+          <a:lnRef idx="1">
+            <a:schemeClr val="accent1"/>
+          </a:lnRef>
+          <a:fillRef idx="3">
+            <a:schemeClr val="accent1"/>
+          </a:fillRef>
+          <a:effectRef idx="2">
+            <a:schemeClr val="accent1"/>
+          </a:effectRef>
+          <a:fontRef idx="minor">
+            <a:schemeClr val="lt1"/>
+          </a:fontRef>
+        </p:style>
+        <p:txBody>
+          <a:bodyPr rtlCol="0" anchor="ctr" wrap="none" lIns="50800" rIns="50800"/>
+          <a:lstStyle/>
+          <a:p>
+            <a:pPr algn="ctr"/>
+            <a:r>
+              <a:rPr sz="1100" b="1">
+                <a:solidFill>
+                  <a:srgbClr val="FFFFFF"/>
+                </a:solidFill>
+                <a:latin typeface="Calibri"/>
+              </a:rPr>
+              <a:t>SAC BRIEFING</a:t>
+            </a:r>
+          </a:p>
+        </p:txBody>
+      </p:sp>
+      <p:sp>
+        <p:nvSpPr>
+          <p:cNvPr id="3" name="TextBox 2"/>
+          <p:cNvSpPr txBox="1"/>
+          <p:nvPr/>
+        </p:nvSpPr>
+        <p:spPr>
+          <a:xfrm>
+            <a:off x="685800" y="1051560"/>
+            <a:ext cx="10607040" cy="822960"/>
+          </a:xfrm>
+          <a:prstGeom prst="rect">
+            <a:avLst/>
+          </a:prstGeom>
+          <a:noFill/>
+        </p:spPr>
+        <p:txBody>
+          <a:bodyPr wrap="square" anchor="t">
+            <a:spAutoFit/>
+          </a:bodyPr>
+          <a:lstStyle/>
+          <a:p>
+            <a:pPr algn="l"/>
+            <a:r>
+              <a:rPr sz="2700" b="1" i="0">
+                <a:solidFill>
+                  <a:srgbClr val="2B2320"/>
+                </a:solidFill>
+                <a:latin typeface="Cambria"/>
+              </a:rPr>
+              <a:t>Outcome 1 (AOS 1) — Analysing Visual Communications</a:t>
+            </a:r>
+          </a:p>
+        </p:txBody>
+      </p:sp>
+      <p:sp>
+        <p:nvSpPr>
+          <p:cNvPr id="4" name="Rounded Rectangle 3"/>
+          <p:cNvSpPr/>
+          <p:nvPr/>
+        </p:nvSpPr>
+        <p:spPr>
+          <a:xfrm>
+            <a:off x="685800" y="1874519"/>
+            <a:ext cx="10607040" cy="4526280"/>
+          </a:xfrm>
+          <a:prstGeom prst="roundRect">
+            <a:avLst>
+              <a:gd name="adj" fmla="val 6000"/>
+            </a:avLst>
+          </a:prstGeom>
+          <a:solidFill>
+            <a:srgbClr val="E8F0F0"/>
+          </a:solidFill>
+          <a:ln>
+            <a:noFill/>
+          </a:ln>
+          <a:effectLst/>
+        </p:spPr>
+        <p:style>
+          <a:lnRef idx="1">
+            <a:schemeClr val="accent1"/>
+          </a:lnRef>
+          <a:fillRef idx="3">
+            <a:schemeClr val="accent1"/>
+          </a:fillRef>
+          <a:effectRef idx="2">
+            <a:schemeClr val="accent1"/>
+          </a:effectRef>
+          <a:fontRef idx="minor">
+            <a:schemeClr val="lt1"/>
+          </a:fontRef>
+        </p:style>
+        <p:txBody>
+          <a:bodyPr rtlCol="0" anchor="ctr" lIns="330200" rIns="330200" tIns="254000" bIns="254000" wrap="square"/>
+          <a:lstStyle/>
+          <a:p>
+            <a:pPr algn="ctr" indent="-203200" marL="203200">
+              <a:spcAft>
+                <a:spcPts val="900"/>
+              </a:spcAft>
+              <a:buClr>
+                <a:srgbClr val="1F6F6B"/>
+              </a:buClr>
+              <a:buSzPct val="90000"/>
+              <a:buFont typeface="Arial"/>
+              <a:buChar char="●"/>
+            </a:pPr>
+            <a:r>
+              <a:rPr sz="1500" b="1" i="0">
+                <a:solidFill>
+                  <a:srgbClr val="1A5E5A"/>
+                </a:solidFill>
+                <a:latin typeface="Calibri"/>
+              </a:rPr>
+              <a:t>Task</a:t>
+            </a:r>
+          </a:p>
+          <a:p>
+            <a:pPr indent="-203200" marL="203200">
+              <a:spcAft>
+                <a:spcPts val="900"/>
+              </a:spcAft>
+              <a:buClr>
+                <a:srgbClr val="1F6F6B"/>
+              </a:buClr>
+              <a:buSzPct val="90000"/>
+              <a:buFont typeface="Arial"/>
+              <a:buChar char="–"/>
+            </a:pPr>
+            <a:r>
+              <a:rPr sz="1350" b="0" i="0">
+                <a:solidFill>
+                  <a:srgbClr val="2B2320"/>
+                </a:solidFill>
+                <a:latin typeface="Calibri"/>
+              </a:rPr>
+              <a:t>Analyse two visual communications provided by the teacher, drawn from two different design fields, applying the elements, principles, gestalt principles and typography concepts studied this term. Respond in structured short-answer format or a written response of approximately 800-1000 words.</a:t>
+            </a:r>
+          </a:p>
+          <a:p>
+            <a:pPr indent="-203200" marL="203200">
+              <a:spcAft>
+                <a:spcPts val="900"/>
+              </a:spcAft>
+              <a:buClr>
+                <a:srgbClr val="1F6F6B"/>
+              </a:buClr>
+              <a:buSzPct val="90000"/>
+              <a:buFont typeface="Arial"/>
+              <a:buChar char="●"/>
+            </a:pPr>
+            <a:r>
+              <a:rPr sz="1500" b="1" i="0">
+                <a:solidFill>
+                  <a:srgbClr val="1A5E5A"/>
+                </a:solidFill>
+                <a:latin typeface="Calibri"/>
+              </a:rPr>
+              <a:t>Conditions</a:t>
+            </a:r>
+          </a:p>
+          <a:p>
+            <a:pPr indent="-203200" marL="203200">
+              <a:spcAft>
+                <a:spcPts val="900"/>
+              </a:spcAft>
+              <a:buClr>
+                <a:srgbClr val="1F6F6B"/>
+              </a:buClr>
+              <a:buSzPct val="90000"/>
+              <a:buFont typeface="Arial"/>
+              <a:buChar char="–"/>
+            </a:pPr>
+            <a:r>
+              <a:rPr sz="1350" b="0" i="0">
+                <a:solidFill>
+                  <a:srgbClr val="2B2320"/>
+                </a:solidFill>
+                <a:latin typeface="Calibri"/>
+              </a:rPr>
+              <a:t>Completed in class over 2 periods (approx. 100 minutes)</a:t>
+            </a:r>
+          </a:p>
+          <a:p>
+            <a:pPr indent="-203200" marL="203200">
+              <a:spcAft>
+                <a:spcPts val="900"/>
+              </a:spcAft>
+              <a:buClr>
+                <a:srgbClr val="1F6F6B"/>
+              </a:buClr>
+              <a:buSzPct val="90000"/>
+              <a:buFont typeface="Arial"/>
+              <a:buChar char="–"/>
+            </a:pPr>
+            <a:r>
+              <a:rPr sz="1350" b="0" i="0">
+                <a:solidFill>
+                  <a:srgbClr val="2B2320"/>
+                </a:solidFill>
+                <a:latin typeface="Calibri"/>
+              </a:rPr>
+              <a:t>Open book: personal notes and handouts permitted; no internet access</a:t>
+            </a:r>
+          </a:p>
+          <a:p>
+            <a:pPr indent="-203200" marL="203200">
+              <a:spcAft>
+                <a:spcPts val="900"/>
+              </a:spcAft>
+              <a:buClr>
+                <a:srgbClr val="1F6F6B"/>
+              </a:buClr>
+              <a:buSzPct val="90000"/>
+              <a:buFont typeface="Arial"/>
+              <a:buChar char="–"/>
+            </a:pPr>
+            <a:r>
+              <a:rPr sz="1350" b="0" i="0">
+                <a:solidFill>
+                  <a:srgbClr val="2B2320"/>
+                </a:solidFill>
+                <a:latin typeface="Calibri"/>
+              </a:rPr>
+              <a:t>Individual, supervised work</a:t>
+            </a:r>
+          </a:p>
+          <a:p>
+            <a:pPr indent="-203200" marL="203200">
+              <a:spcAft>
+                <a:spcPts val="900"/>
+              </a:spcAft>
+              <a:buClr>
+                <a:srgbClr val="1F6F6B"/>
+              </a:buClr>
+              <a:buSzPct val="90000"/>
+              <a:buFont typeface="Arial"/>
+              <a:buChar char="●"/>
+            </a:pPr>
+            <a:r>
+              <a:rPr sz="1500" b="1" i="0">
+                <a:solidFill>
+                  <a:srgbClr val="1A5E5A"/>
+                </a:solidFill>
+                <a:latin typeface="Calibri"/>
+              </a:rPr>
+              <a:t>Assessment Criteria (/40)</a:t>
+            </a:r>
+          </a:p>
+          <a:p>
+            <a:pPr indent="-203200" marL="203200">
+              <a:spcAft>
+                <a:spcPts val="900"/>
+              </a:spcAft>
+              <a:buClr>
+                <a:srgbClr val="1F6F6B"/>
+              </a:buClr>
+              <a:buSzPct val="90000"/>
+              <a:buFont typeface="Arial"/>
+              <a:buChar char="–"/>
+            </a:pPr>
+            <a:r>
+              <a:rPr sz="1350" b="0" i="0">
+                <a:solidFill>
+                  <a:srgbClr val="2B2320"/>
+                </a:solidFill>
+                <a:latin typeface="Calibri"/>
+              </a:rPr>
+              <a:t>Accurate use of design terminology — 10 marks</a:t>
+            </a:r>
+          </a:p>
+          <a:p>
+            <a:pPr indent="-203200" marL="203200">
+              <a:spcAft>
+                <a:spcPts val="900"/>
+              </a:spcAft>
+              <a:buClr>
+                <a:srgbClr val="1F6F6B"/>
+              </a:buClr>
+              <a:buSzPct val="90000"/>
+              <a:buFont typeface="Arial"/>
+              <a:buChar char="–"/>
+            </a:pPr>
+            <a:r>
+              <a:rPr sz="1350" b="0" i="0">
+                <a:solidFill>
+                  <a:srgbClr val="2B2320"/>
+                </a:solidFill>
+                <a:latin typeface="Calibri"/>
+              </a:rPr>
+              <a:t>Depth of analysis using Name -&gt; Evidence -&gt; Effect — 15 marks</a:t>
+            </a:r>
+          </a:p>
+          <a:p>
+            <a:pPr indent="-203200" marL="203200">
+              <a:spcAft>
+                <a:spcPts val="900"/>
+              </a:spcAft>
+              <a:buClr>
+                <a:srgbClr val="1F6F6B"/>
+              </a:buClr>
+              <a:buSzPct val="90000"/>
+              <a:buFont typeface="Arial"/>
+              <a:buChar char="–"/>
+            </a:pPr>
+            <a:r>
+              <a:rPr sz="1350" b="0" i="0">
+                <a:solidFill>
+                  <a:srgbClr val="2B2320"/>
+                </a:solidFill>
+                <a:latin typeface="Calibri"/>
+              </a:rPr>
+              <a:t>Range of elements, principles and gestalt principles discussed — 10 marks</a:t>
+            </a:r>
+          </a:p>
+          <a:p>
+            <a:pPr indent="-203200" marL="203200">
+              <a:spcAft>
+                <a:spcPts val="900"/>
+              </a:spcAft>
+              <a:buClr>
+                <a:srgbClr val="1F6F6B"/>
+              </a:buClr>
+              <a:buSzPct val="90000"/>
+              <a:buFont typeface="Arial"/>
+              <a:buChar char="–"/>
+            </a:pPr>
+            <a:r>
+              <a:rPr sz="1350" b="0" i="0">
+                <a:solidFill>
+                  <a:srgbClr val="2B2320"/>
+                </a:solidFill>
+                <a:latin typeface="Calibri"/>
+              </a:rPr>
+              <a:t>Clarity of written expression — 5 marks</a:t>
+            </a:r>
+          </a:p>
+        </p:txBody>
+      </p:sp>
+      <p:sp>
+        <p:nvSpPr>
+          <p:cNvPr id="5" name="Oval 4"/>
+          <p:cNvSpPr/>
+          <p:nvPr/>
+        </p:nvSpPr>
+        <p:spPr>
+          <a:xfrm>
+            <a:off x="10881360" y="5943600"/>
+            <a:ext cx="1005840" cy="1005840"/>
+          </a:xfrm>
+          <a:prstGeom prst="ellipse">
+            <a:avLst/>
+          </a:prstGeom>
+          <a:solidFill>
+            <a:srgbClr val="F4B8C3"/>
+          </a:solidFill>
+          <a:ln>
+            <a:noFill/>
+          </a:ln>
+          <a:effectLst/>
+        </p:spPr>
+        <p:style>
+          <a:lnRef idx="1">
+            <a:schemeClr val="accent1"/>
+          </a:lnRef>
+          <a:fillRef idx="3">
+            <a:schemeClr val="accent1"/>
+          </a:fillRef>
+          <a:effectRef idx="2">
+            <a:schemeClr val="accent1"/>
+          </a:effectRef>
+          <a:fontRef idx="minor">
+            <a:schemeClr val="lt1"/>
+          </a:fontRef>
+        </p:style>
+        <p:txBody>
+          <a:bodyPr rtlCol="0" anchor="ctr"/>
+          <a:lstStyle/>
+          <a:p>
+            <a:pPr algn="ctr"/>
+          </a:p>
+        </p:txBody>
+      </p:sp>
+    </p:spTree>
+  </p:cSld>
+  <p:clrMapOvr>
+    <a:masterClrMapping/>
+  </p:clrMapOvr>
+</p:sld>
+</file>
+
+<file path=ppt/slides/slide69.xml><?xml version="1.0" encoding="utf-8"?>
+<p:sld xmlns:a="http://schemas.openxmlformats.org/drawingml/2006/main" xmlns:p="http://schemas.openxmlformats.org/presentationml/2006/main" xmlns:r="http://schemas.openxmlformats.org/officeDocument/2006/relationships">
+  <p:cSld>
+    <p:bg>
+      <p:bgPr>
+        <a:solidFill>
+          <a:srgbClr val="FCF8F1"/>
+        </a:solidFill>
+        <a:effectLst/>
+      </p:bgPr>
+    </p:bg>
+    <p:spTree>
+      <p:nvGrpSpPr>
+        <p:cNvPr id="1" name=""/>
+        <p:cNvGrpSpPr/>
+        <p:nvPr/>
+      </p:nvGrpSpPr>
+      <p:grpSpPr/>
+      <p:sp>
+        <p:nvSpPr>
+          <p:cNvPr id="2" name="Rounded Rectangle 1"/>
+          <p:cNvSpPr/>
+          <p:nvPr/>
+        </p:nvSpPr>
+        <p:spPr>
+          <a:xfrm>
+            <a:off x="685800" y="502920"/>
+            <a:ext cx="3291840" cy="457200"/>
+          </a:xfrm>
+          <a:prstGeom prst="roundRect">
+            <a:avLst>
+              <a:gd name="adj" fmla="val 50000"/>
+            </a:avLst>
+          </a:prstGeom>
+          <a:solidFill>
+            <a:srgbClr val="1F6F6B"/>
+          </a:solidFill>
+          <a:ln>
+            <a:noFill/>
+          </a:ln>
+          <a:effectLst/>
+        </p:spPr>
+        <p:style>
+          <a:lnRef idx="1">
+            <a:schemeClr val="accent1"/>
+          </a:lnRef>
+          <a:fillRef idx="3">
+            <a:schemeClr val="accent1"/>
+          </a:fillRef>
+          <a:effectRef idx="2">
+            <a:schemeClr val="accent1"/>
+          </a:effectRef>
+          <a:fontRef idx="minor">
+            <a:schemeClr val="lt1"/>
+          </a:fontRef>
+        </p:style>
+        <p:txBody>
+          <a:bodyPr rtlCol="0" anchor="ctr" wrap="none" lIns="50800" rIns="50800"/>
+          <a:lstStyle/>
+          <a:p>
+            <a:pPr algn="ctr"/>
+            <a:r>
+              <a:rPr sz="1100" b="1">
+                <a:solidFill>
+                  <a:srgbClr val="FFFFFF"/>
+                </a:solidFill>
+                <a:latin typeface="Calibri"/>
+              </a:rPr>
+              <a:t>SAC BRIEFING</a:t>
+            </a:r>
+          </a:p>
+        </p:txBody>
+      </p:sp>
+      <p:sp>
+        <p:nvSpPr>
+          <p:cNvPr id="3" name="TextBox 2"/>
+          <p:cNvSpPr txBox="1"/>
+          <p:nvPr/>
+        </p:nvSpPr>
+        <p:spPr>
+          <a:xfrm>
+            <a:off x="685800" y="1051560"/>
+            <a:ext cx="10607040" cy="822960"/>
+          </a:xfrm>
+          <a:prstGeom prst="rect">
+            <a:avLst/>
+          </a:prstGeom>
+          <a:noFill/>
+        </p:spPr>
+        <p:txBody>
+          <a:bodyPr wrap="square" anchor="t">
+            <a:spAutoFit/>
+          </a:bodyPr>
+          <a:lstStyle/>
+          <a:p>
+            <a:pPr algn="l"/>
+            <a:r>
+              <a:rPr sz="2700" b="1" i="0">
+                <a:solidFill>
+                  <a:srgbClr val="2B2320"/>
+                </a:solidFill>
+                <a:latin typeface="Cambria"/>
+              </a:rPr>
+              <a:t>Outcome 2 (AOS 2) — Applying Design Thinking to a Brief</a:t>
+            </a:r>
+          </a:p>
+        </p:txBody>
+      </p:sp>
+      <p:sp>
+        <p:nvSpPr>
+          <p:cNvPr id="4" name="Rounded Rectangle 3"/>
+          <p:cNvSpPr/>
+          <p:nvPr/>
+        </p:nvSpPr>
+        <p:spPr>
+          <a:xfrm>
+            <a:off x="685800" y="1874519"/>
+            <a:ext cx="10607040" cy="4526280"/>
+          </a:xfrm>
+          <a:prstGeom prst="roundRect">
+            <a:avLst>
+              <a:gd name="adj" fmla="val 6000"/>
+            </a:avLst>
+          </a:prstGeom>
+          <a:solidFill>
+            <a:srgbClr val="E8F0F0"/>
+          </a:solidFill>
+          <a:ln>
+            <a:noFill/>
+          </a:ln>
+          <a:effectLst/>
+        </p:spPr>
+        <p:style>
+          <a:lnRef idx="1">
+            <a:schemeClr val="accent1"/>
+          </a:lnRef>
+          <a:fillRef idx="3">
+            <a:schemeClr val="accent1"/>
+          </a:fillRef>
+          <a:effectRef idx="2">
+            <a:schemeClr val="accent1"/>
+          </a:effectRef>
+          <a:fontRef idx="minor">
+            <a:schemeClr val="lt1"/>
+          </a:fontRef>
+        </p:style>
+        <p:txBody>
+          <a:bodyPr rtlCol="0" anchor="ctr" lIns="330200" rIns="330200" tIns="254000" bIns="254000" wrap="square"/>
+          <a:lstStyle/>
+          <a:p>
+            <a:pPr algn="ctr" indent="-203200" marL="203200">
+              <a:spcAft>
+                <a:spcPts val="900"/>
+              </a:spcAft>
+              <a:buClr>
+                <a:srgbClr val="1F6F6B"/>
+              </a:buClr>
+              <a:buSzPct val="90000"/>
+              <a:buFont typeface="Arial"/>
+              <a:buChar char="●"/>
+            </a:pPr>
+            <a:r>
+              <a:rPr sz="1500" b="1" i="0">
+                <a:solidFill>
+                  <a:srgbClr val="1A5E5A"/>
+                </a:solidFill>
+                <a:latin typeface="Calibri"/>
+              </a:rPr>
+              <a:t>Task</a:t>
+            </a:r>
+          </a:p>
+          <a:p>
+            <a:pPr indent="-203200" marL="203200">
+              <a:spcAft>
+                <a:spcPts val="900"/>
+              </a:spcAft>
+              <a:buClr>
+                <a:srgbClr val="1F6F6B"/>
+              </a:buClr>
+              <a:buSzPct val="90000"/>
+              <a:buFont typeface="Arial"/>
+              <a:buChar char="–"/>
+            </a:pPr>
+            <a:r>
+              <a:rPr sz="1350" b="0" i="0">
+                <a:solidFill>
+                  <a:srgbClr val="2B2320"/>
+                </a:solidFill>
+                <a:latin typeface="Calibri"/>
+              </a:rPr>
+              <a:t>Respond to a given design brief by working through the design process: undertake research, generate a minimum of 10 thumbnail sketches exploring ideas, develop one idea with annotations, and produce a final presentation drawing using an appropriate method (orthogonal, isometric or perspective) for one of the four design fields specified in the brief.</a:t>
+            </a:r>
+          </a:p>
+          <a:p>
+            <a:pPr indent="-203200" marL="203200">
+              <a:spcAft>
+                <a:spcPts val="900"/>
+              </a:spcAft>
+              <a:buClr>
+                <a:srgbClr val="1F6F6B"/>
+              </a:buClr>
+              <a:buSzPct val="90000"/>
+              <a:buFont typeface="Arial"/>
+              <a:buChar char="●"/>
+            </a:pPr>
+            <a:r>
+              <a:rPr sz="1500" b="1" i="0">
+                <a:solidFill>
+                  <a:srgbClr val="1A5E5A"/>
+                </a:solidFill>
+                <a:latin typeface="Calibri"/>
+              </a:rPr>
+              <a:t>Conditions</a:t>
+            </a:r>
+          </a:p>
+          <a:p>
+            <a:pPr indent="-203200" marL="203200">
+              <a:spcAft>
+                <a:spcPts val="900"/>
+              </a:spcAft>
+              <a:buClr>
+                <a:srgbClr val="1F6F6B"/>
+              </a:buClr>
+              <a:buSzPct val="90000"/>
+              <a:buFont typeface="Arial"/>
+              <a:buChar char="–"/>
+            </a:pPr>
+            <a:r>
+              <a:rPr sz="1350" b="0" i="0">
+                <a:solidFill>
+                  <a:srgbClr val="2B2320"/>
+                </a:solidFill>
+                <a:latin typeface="Calibri"/>
+              </a:rPr>
+              <a:t>Completed over approximately 4-5 weeks, in class with supervised homework components</a:t>
+            </a:r>
+          </a:p>
+          <a:p>
+            <a:pPr indent="-203200" marL="203200">
+              <a:spcAft>
+                <a:spcPts val="900"/>
+              </a:spcAft>
+              <a:buClr>
+                <a:srgbClr val="1F6F6B"/>
+              </a:buClr>
+              <a:buSzPct val="90000"/>
+              <a:buFont typeface="Arial"/>
+              <a:buChar char="–"/>
+            </a:pPr>
+            <a:r>
+              <a:rPr sz="1350" b="0" i="0">
+                <a:solidFill>
+                  <a:srgbClr val="2B2320"/>
+                </a:solidFill>
+                <a:latin typeface="Calibri"/>
+              </a:rPr>
+              <a:t>Folio submission (physical or digital) combining process work and final presentation</a:t>
+            </a:r>
+          </a:p>
+          <a:p>
+            <a:pPr indent="-203200" marL="203200">
+              <a:spcAft>
+                <a:spcPts val="900"/>
+              </a:spcAft>
+              <a:buClr>
+                <a:srgbClr val="1F6F6B"/>
+              </a:buClr>
+              <a:buSzPct val="90000"/>
+              <a:buFont typeface="Arial"/>
+              <a:buChar char="–"/>
+            </a:pPr>
+            <a:r>
+              <a:rPr sz="1350" b="0" i="0">
+                <a:solidFill>
+                  <a:srgbClr val="2B2320"/>
+                </a:solidFill>
+                <a:latin typeface="Calibri"/>
+              </a:rPr>
+              <a:t>Individual work</a:t>
+            </a:r>
+          </a:p>
+          <a:p>
+            <a:pPr indent="-203200" marL="203200">
+              <a:spcAft>
+                <a:spcPts val="900"/>
+              </a:spcAft>
+              <a:buClr>
+                <a:srgbClr val="1F6F6B"/>
+              </a:buClr>
+              <a:buSzPct val="90000"/>
+              <a:buFont typeface="Arial"/>
+              <a:buChar char="●"/>
+            </a:pPr>
+            <a:r>
+              <a:rPr sz="1500" b="1" i="0">
+                <a:solidFill>
+                  <a:srgbClr val="1A5E5A"/>
+                </a:solidFill>
+                <a:latin typeface="Calibri"/>
+              </a:rPr>
+              <a:t>Assessment Criteria (/60)</a:t>
+            </a:r>
+          </a:p>
+          <a:p>
+            <a:pPr indent="-203200" marL="203200">
+              <a:spcAft>
+                <a:spcPts val="900"/>
+              </a:spcAft>
+              <a:buClr>
+                <a:srgbClr val="1F6F6B"/>
+              </a:buClr>
+              <a:buSzPct val="90000"/>
+              <a:buFont typeface="Arial"/>
+              <a:buChar char="–"/>
+            </a:pPr>
+            <a:r>
+              <a:rPr sz="1350" b="0" i="0">
+                <a:solidFill>
+                  <a:srgbClr val="2B2320"/>
+                </a:solidFill>
+                <a:latin typeface="Calibri"/>
+              </a:rPr>
+              <a:t>Evidence of research — 10 marks</a:t>
+            </a:r>
+          </a:p>
+          <a:p>
+            <a:pPr indent="-203200" marL="203200">
+              <a:spcAft>
+                <a:spcPts val="900"/>
+              </a:spcAft>
+              <a:buClr>
+                <a:srgbClr val="1F6F6B"/>
+              </a:buClr>
+              <a:buSzPct val="90000"/>
+              <a:buFont typeface="Arial"/>
+              <a:buChar char="–"/>
+            </a:pPr>
+            <a:r>
+              <a:rPr sz="1350" b="0" i="0">
+                <a:solidFill>
+                  <a:srgbClr val="2B2320"/>
+                </a:solidFill>
+                <a:latin typeface="Calibri"/>
+              </a:rPr>
+              <a:t>Range and quality of generated ideas — 15 marks</a:t>
+            </a:r>
+          </a:p>
+          <a:p>
+            <a:pPr indent="-203200" marL="203200">
+              <a:spcAft>
+                <a:spcPts val="900"/>
+              </a:spcAft>
+              <a:buClr>
+                <a:srgbClr val="1F6F6B"/>
+              </a:buClr>
+              <a:buSzPct val="90000"/>
+              <a:buFont typeface="Arial"/>
+              <a:buChar char="–"/>
+            </a:pPr>
+            <a:r>
+              <a:rPr sz="1350" b="0" i="0">
+                <a:solidFill>
+                  <a:srgbClr val="2B2320"/>
+                </a:solidFill>
+                <a:latin typeface="Calibri"/>
+              </a:rPr>
+              <a:t>Development and annotation of the chosen idea — 15 marks</a:t>
+            </a:r>
+          </a:p>
+          <a:p>
+            <a:pPr indent="-203200" marL="203200">
+              <a:spcAft>
+                <a:spcPts val="900"/>
+              </a:spcAft>
+              <a:buClr>
+                <a:srgbClr val="1F6F6B"/>
+              </a:buClr>
+              <a:buSzPct val="90000"/>
+              <a:buFont typeface="Arial"/>
+              <a:buChar char="–"/>
+            </a:pPr>
+            <a:r>
+              <a:rPr sz="1350" b="0" i="0">
+                <a:solidFill>
+                  <a:srgbClr val="2B2320"/>
+                </a:solidFill>
+                <a:latin typeface="Calibri"/>
+              </a:rPr>
+              <a:t>Accuracy and finish of the presentation drawing — 15 marks</a:t>
+            </a:r>
+          </a:p>
+          <a:p>
+            <a:pPr indent="-203200" marL="203200">
+              <a:spcAft>
+                <a:spcPts val="900"/>
+              </a:spcAft>
+              <a:buClr>
+                <a:srgbClr val="1F6F6B"/>
+              </a:buClr>
+              <a:buSzPct val="90000"/>
+              <a:buFont typeface="Arial"/>
+              <a:buChar char="–"/>
+            </a:pPr>
+            <a:r>
+              <a:rPr sz="1350" b="0" i="0">
+                <a:solidFill>
+                  <a:srgbClr val="2B2320"/>
+                </a:solidFill>
+                <a:latin typeface="Calibri"/>
+              </a:rPr>
+              <a:t>Adherence to the brief — 5 marks</a:t>
+            </a:r>
+          </a:p>
+        </p:txBody>
+      </p:sp>
+      <p:sp>
+        <p:nvSpPr>
+          <p:cNvPr id="5" name="Oval 4"/>
+          <p:cNvSpPr/>
+          <p:nvPr/>
+        </p:nvSpPr>
+        <p:spPr>
+          <a:xfrm>
+            <a:off x="10881360" y="5943600"/>
+            <a:ext cx="1005840" cy="1005840"/>
+          </a:xfrm>
+          <a:prstGeom prst="ellipse">
+            <a:avLst/>
+          </a:prstGeom>
+          <a:solidFill>
+            <a:srgbClr val="F4B8C3"/>
+          </a:solidFill>
+          <a:ln>
+            <a:noFill/>
+          </a:ln>
+          <a:effectLst/>
+        </p:spPr>
+        <p:style>
+          <a:lnRef idx="1">
+            <a:schemeClr val="accent1"/>
+          </a:lnRef>
+          <a:fillRef idx="3">
+            <a:schemeClr val="accent1"/>
+          </a:fillRef>
+          <a:effectRef idx="2">
+            <a:schemeClr val="accent1"/>
+          </a:effectRef>
+          <a:fontRef idx="minor">
+            <a:schemeClr val="lt1"/>
+          </a:fontRef>
+        </p:style>
+        <p:txBody>
+          <a:bodyPr rtlCol="0" anchor="ctr"/>
+          <a:lstStyle/>
+          <a:p>
+            <a:pPr algn="ctr"/>
           </a:p>
         </p:txBody>
       </p:sp>
@@ -29061,6 +32625,186 @@
           <a:lstStyle/>
           <a:p>
             <a:pPr algn="ctr"/>
+          </a:p>
+        </p:txBody>
+      </p:sp>
+    </p:spTree>
+  </p:cSld>
+  <p:clrMapOvr>
+    <a:masterClrMapping/>
+  </p:clrMapOvr>
+</p:sld>
+</file>
+
+<file path=ppt/slides/slide70.xml><?xml version="1.0" encoding="utf-8"?>
+<p:sld xmlns:a="http://schemas.openxmlformats.org/drawingml/2006/main" xmlns:p="http://schemas.openxmlformats.org/presentationml/2006/main" xmlns:r="http://schemas.openxmlformats.org/officeDocument/2006/relationships">
+  <p:cSld>
+    <p:bg>
+      <p:bgPr>
+        <a:solidFill>
+          <a:srgbClr val="1F6F6B"/>
+        </a:solidFill>
+        <a:effectLst/>
+      </p:bgPr>
+    </p:bg>
+    <p:spTree>
+      <p:nvGrpSpPr>
+        <p:cNvPr id="1" name=""/>
+        <p:cNvGrpSpPr/>
+        <p:nvPr/>
+      </p:nvGrpSpPr>
+      <p:grpSpPr/>
+      <p:sp>
+        <p:nvSpPr>
+          <p:cNvPr id="2" name="Oval 1"/>
+          <p:cNvSpPr/>
+          <p:nvPr/>
+        </p:nvSpPr>
+        <p:spPr>
+          <a:xfrm>
+            <a:off x="-1097280" y="4114800"/>
+            <a:ext cx="3108960" cy="3108960"/>
+          </a:xfrm>
+          <a:prstGeom prst="ellipse">
+            <a:avLst/>
+          </a:prstGeom>
+          <a:solidFill>
+            <a:srgbClr val="1B615E"/>
+          </a:solidFill>
+          <a:ln>
+            <a:noFill/>
+          </a:ln>
+          <a:effectLst/>
+        </p:spPr>
+        <p:style>
+          <a:lnRef idx="1">
+            <a:schemeClr val="accent1"/>
+          </a:lnRef>
+          <a:fillRef idx="3">
+            <a:schemeClr val="accent1"/>
+          </a:fillRef>
+          <a:effectRef idx="2">
+            <a:schemeClr val="accent1"/>
+          </a:effectRef>
+          <a:fontRef idx="minor">
+            <a:schemeClr val="lt1"/>
+          </a:fontRef>
+        </p:style>
+        <p:txBody>
+          <a:bodyPr rtlCol="0" anchor="ctr"/>
+          <a:lstStyle/>
+          <a:p>
+            <a:pPr algn="ctr"/>
+          </a:p>
+        </p:txBody>
+      </p:sp>
+      <p:sp>
+        <p:nvSpPr>
+          <p:cNvPr id="3" name="Oval 2"/>
+          <p:cNvSpPr/>
+          <p:nvPr/>
+        </p:nvSpPr>
+        <p:spPr>
+          <a:xfrm>
+            <a:off x="9875520" y="-1188720"/>
+            <a:ext cx="2743200" cy="2743200"/>
+          </a:xfrm>
+          <a:prstGeom prst="ellipse">
+            <a:avLst/>
+          </a:prstGeom>
+          <a:solidFill>
+            <a:srgbClr val="E8A23A"/>
+          </a:solidFill>
+          <a:ln>
+            <a:noFill/>
+          </a:ln>
+          <a:effectLst/>
+        </p:spPr>
+        <p:style>
+          <a:lnRef idx="1">
+            <a:schemeClr val="accent1"/>
+          </a:lnRef>
+          <a:fillRef idx="3">
+            <a:schemeClr val="accent1"/>
+          </a:fillRef>
+          <a:effectRef idx="2">
+            <a:schemeClr val="accent1"/>
+          </a:effectRef>
+          <a:fontRef idx="minor">
+            <a:schemeClr val="lt1"/>
+          </a:fontRef>
+        </p:style>
+        <p:txBody>
+          <a:bodyPr rtlCol="0" anchor="ctr"/>
+          <a:lstStyle/>
+          <a:p>
+            <a:pPr algn="ctr"/>
+          </a:p>
+        </p:txBody>
+      </p:sp>
+      <p:sp>
+        <p:nvSpPr>
+          <p:cNvPr id="4" name="Rounded Rectangle 3"/>
+          <p:cNvSpPr/>
+          <p:nvPr/>
+        </p:nvSpPr>
+        <p:spPr>
+          <a:xfrm>
+            <a:off x="1920240" y="2286000"/>
+            <a:ext cx="8321040" cy="2377440"/>
+          </a:xfrm>
+          <a:prstGeom prst="roundRect">
+            <a:avLst>
+              <a:gd name="adj" fmla="val 20000"/>
+            </a:avLst>
+          </a:prstGeom>
+          <a:solidFill>
+            <a:srgbClr val="FFFFFF"/>
+          </a:solidFill>
+          <a:ln>
+            <a:noFill/>
+          </a:ln>
+          <a:effectLst/>
+        </p:spPr>
+        <p:style>
+          <a:lnRef idx="1">
+            <a:schemeClr val="accent1"/>
+          </a:lnRef>
+          <a:fillRef idx="3">
+            <a:schemeClr val="accent1"/>
+          </a:fillRef>
+          <a:effectRef idx="2">
+            <a:schemeClr val="accent1"/>
+          </a:effectRef>
+          <a:fontRef idx="minor">
+            <a:schemeClr val="lt1"/>
+          </a:fontRef>
+        </p:style>
+        <p:txBody>
+          <a:bodyPr rtlCol="0" anchor="ctr"/>
+          <a:lstStyle/>
+          <a:p>
+            <a:pPr algn="ctr"/>
+            <a:r>
+              <a:rPr b="1" sz="3000">
+                <a:solidFill>
+                  <a:srgbClr val="1F6F6B"/>
+                </a:solidFill>
+                <a:latin typeface="Cambria"/>
+              </a:rPr>
+              <a:t>End of Unit 1</a:t>
+            </a:r>
+          </a:p>
+          <a:p>
+            <a:pPr algn="ctr"/>
+            <a:r>
+              <a:rPr sz="1400">
+                <a:solidFill>
+                  <a:srgbClr val="595959"/>
+                </a:solidFill>
+              </a:rPr>
+              <a:t>Review the matching workbook to consolidate what you have learnt.</a:t>
+            </a:r>
           </a:p>
         </p:txBody>
       </p:sp>

</xml_diff>